<commit_message>
docs: real kernel metrics after link_state + model_cache removal
Replace the pre-change table values with measured BPF_PROG_TEST_RUN numbers
(test_suite.py --only kernel, 4 CPU, scale 24): P1 264 B map memory (was 83 KB
with model_cache), P2 fastest (339 ns), link_state cost +38 instr on P1 / +~930
on P2. Update HTML, testing.md and the 17-slide deck; drop the re-measure note.
</commit_message>
<xml_diff>
--- a/docs/IPA_eBPF_pipelines.pptx
+++ b/docs/IPA_eBPF_pipelines.pptx
@@ -7712,7 +7712,7 @@
                           </a:solidFill>
                           <a:latin typeface="Consolas"/>
                         </a:rPr>
-                        <a:t>1 057</a:t>
+                        <a:t>1 095</a:t>
                       </a:r>
                     </a:p>
                   </a:txBody>
@@ -7735,7 +7735,7 @@
                           </a:solidFill>
                           <a:latin typeface="Consolas"/>
                         </a:rPr>
-                        <a:t>1 968</a:t>
+                        <a:t>2 897</a:t>
                       </a:r>
                     </a:p>
                   </a:txBody>
@@ -7758,7 +7758,7 @@
                           </a:solidFill>
                           <a:latin typeface="Consolas"/>
                         </a:rPr>
-                        <a:t>13 488</a:t>
+                        <a:t>13 645</a:t>
                       </a:r>
                     </a:p>
                   </a:txBody>
@@ -7806,7 +7806,7 @@
                           </a:solidFill>
                           <a:latin typeface="Consolas"/>
                         </a:rPr>
-                        <a:t>5 081</a:t>
+                        <a:t>5 132</a:t>
                       </a:r>
                     </a:p>
                   </a:txBody>
@@ -7829,7 +7829,7 @@
                           </a:solidFill>
                           <a:latin typeface="Consolas"/>
                         </a:rPr>
-                        <a:t>8 766</a:t>
+                        <a:t>12 575</a:t>
                       </a:r>
                     </a:p>
                   </a:txBody>
@@ -7852,7 +7852,7 @@
                           </a:solidFill>
                           <a:latin typeface="Consolas"/>
                         </a:rPr>
-                        <a:t>57 523</a:t>
+                        <a:t>58 146</a:t>
                       </a:r>
                     </a:p>
                   </a:txBody>
@@ -7994,7 +7994,7 @@
                           </a:solidFill>
                           <a:latin typeface="Consolas"/>
                         </a:rPr>
-                        <a:t>~264 †</a:t>
+                        <a:t>264</a:t>
                       </a:r>
                     </a:p>
                   </a:txBody>
@@ -8017,7 +8017,7 @@
                           </a:solidFill>
                           <a:latin typeface="Consolas"/>
                         </a:rPr>
-                        <a:t>15 748</a:t>
+                        <a:t>15 796</a:t>
                       </a:r>
                     </a:p>
                   </a:txBody>
@@ -8040,7 +8040,7 @@
                           </a:solidFill>
                           <a:latin typeface="Consolas"/>
                         </a:rPr>
-                        <a:t>28 420</a:t>
+                        <a:t>28 468</a:t>
                       </a:r>
                     </a:p>
                   </a:txBody>
@@ -8088,7 +8088,7 @@
                           </a:solidFill>
                           <a:latin typeface="Consolas"/>
                         </a:rPr>
-                        <a:t>1030.0</a:t>
+                        <a:t>1109.0</a:t>
                       </a:r>
                     </a:p>
                   </a:txBody>
@@ -8111,7 +8111,7 @@
                           </a:solidFill>
                           <a:latin typeface="Consolas"/>
                         </a:rPr>
-                        <a:t>131.0</a:t>
+                        <a:t>339.0</a:t>
                       </a:r>
                     </a:p>
                   </a:txBody>
@@ -8134,7 +8134,7 @@
                           </a:solidFill>
                           <a:latin typeface="Consolas"/>
                         </a:rPr>
-                        <a:t>562.0</a:t>
+                        <a:t>1291.0</a:t>
                       </a:r>
                     </a:p>
                   </a:txBody>
@@ -8182,7 +8182,7 @@
                           </a:solidFill>
                           <a:latin typeface="Consolas"/>
                         </a:rPr>
-                        <a:t>0.971</a:t>
+                        <a:t>0.902</a:t>
                       </a:r>
                     </a:p>
                   </a:txBody>
@@ -8205,7 +8205,7 @@
                           </a:solidFill>
                           <a:latin typeface="Consolas"/>
                         </a:rPr>
-                        <a:t>7.634</a:t>
+                        <a:t>2.950</a:t>
                       </a:r>
                     </a:p>
                   </a:txBody>
@@ -8228,7 +8228,7 @@
                           </a:solidFill>
                           <a:latin typeface="Consolas"/>
                         </a:rPr>
-                        <a:t>1.779</a:t>
+                        <a:t>0.775</a:t>
                       </a:r>
                     </a:p>
                   </a:txBody>
@@ -8276,7 +8276,7 @@
                           </a:solidFill>
                           <a:latin typeface="Consolas"/>
                         </a:rPr>
-                        <a:t>59</a:t>
+                        <a:t>60</a:t>
                       </a:r>
                     </a:p>
                   </a:txBody>
@@ -8299,7 +8299,7 @@
                           </a:solidFill>
                           <a:latin typeface="Consolas"/>
                         </a:rPr>
-                        <a:t>29</a:t>
+                        <a:t>48</a:t>
                       </a:r>
                     </a:p>
                   </a:txBody>
@@ -8322,7 +8322,7 @@
                           </a:solidFill>
                           <a:latin typeface="Consolas"/>
                         </a:rPr>
-                        <a:t>57</a:t>
+                        <a:t>79</a:t>
                       </a:r>
                     </a:p>
                   </a:txBody>
@@ -8454,7 +8454,7 @@
                 </a:solidFill>
                 <a:latin typeface="Segoe UI"/>
               </a:rPr>
-              <a:t>P2 più veloce (131 ns).</a:t>
+              <a:t>P2 più veloce (339 ns).</a:t>
             </a:r>
           </a:p>
           <a:p>
@@ -8485,7 +8485,7 @@
                 </a:solidFill>
                 <a:latin typeface="Segoe UI"/>
               </a:rPr>
-              <a:t>P1 hardcoded puro: memoria mappe minima.</a:t>
+              <a:t>P1 hardcoded puro: solo 264 B di mappe.</a:t>
             </a:r>
           </a:p>
           <a:p>
@@ -8516,7 +8516,7 @@
                 </a:solidFill>
                 <a:latin typeface="Segoe UI"/>
               </a:rPr>
-              <a:t>P3 ≈13× istruzioni di P1.</a:t>
+              <a:t>P3 ≈12× istruzioni di P1.</a:t>
             </a:r>
           </a:p>
         </p:txBody>
@@ -8561,7 +8561,7 @@
                 </a:solidFill>
                 <a:latin typeface="Segoe UI"/>
               </a:rPr>
-              <a:t>† Rimisurare: </a:t>
+              <a:t>Misurato dopo link_state reale + rimozione di model_cache: </a:t>
             </a:r>
             <a:r>
               <a:rPr sz="1200" b="0">
@@ -8570,7 +8570,7 @@
                 </a:solidFill>
                 <a:latin typeface="Segoe UI"/>
               </a:rPr>
-              <a:t>tabella raccolta prima della rimozione di model_cache (P1 hardcoded puro) e del link_state reale. Memoria P1 attesa 83 KB → ~264 B; +~30–40 istruzioni per i 6 lookup link_state; latenza ~invariata.</a:t>
+              <a:t>la memoria mappe di P1 crolla da 83 KB a 264 B (model_cache era il 99%); il popolamento link_state costa +38 istruzioni su P1, +~930 su P2. Latenza/throughput hanno varianza run-to-run.</a:t>
             </a:r>
           </a:p>
         </p:txBody>

</xml_diff>

<commit_message>
Frame the perf-vs-flexibility trade-off; add map-lookup metric; drop dead code
- Add the map-lookup/packet metric (professor's taxonomy) to the results
  tables: P1 8 (0 weight lookups) < P2 322 < P3 384, making the structural
  cost of flexibility explicit alongside tail calls and instructions.
- Fix the userspace design-space estimate for P1 (no model_cache): map memory
  ~264 B and lookups 6 link_state + 2 counters.
- Remove the dead ipa_dispatcher/model_progs branch from setup_hardcoded
  (pure hardcoded is a single leaf program, no tail-call map).
</commit_message>
<xml_diff>
--- a/docs/IPA_eBPF_pipelines.pptx
+++ b/docs/IPA_eBPF_pipelines.pptx
@@ -7581,7 +7581,7 @@
                 <a:gridCol w="1764792"/>
                 <a:gridCol w="1764792"/>
               </a:tblGrid>
-              <a:tr h="422910">
+              <a:tr h="375920">
                 <a:tc>
                   <a:txBody>
                     <a:bodyPr/>
@@ -7675,7 +7675,7 @@
                   </a:tcPr>
                 </a:tc>
               </a:tr>
-              <a:tr h="422910">
+              <a:tr h="375920">
                 <a:tc>
                   <a:txBody>
                     <a:bodyPr/>
@@ -7769,7 +7769,7 @@
                   </a:tcPr>
                 </a:tc>
               </a:tr>
-              <a:tr h="422910">
+              <a:tr h="375920">
                 <a:tc>
                   <a:txBody>
                     <a:bodyPr/>
@@ -7863,7 +7863,7 @@
                   </a:tcPr>
                 </a:tc>
               </a:tr>
-              <a:tr h="422910">
+              <a:tr h="375920">
                 <a:tc>
                   <a:txBody>
                     <a:bodyPr/>
@@ -7957,7 +7957,7 @@
                   </a:tcPr>
                 </a:tc>
               </a:tr>
-              <a:tr h="422910">
+              <a:tr h="375920">
                 <a:tc>
                   <a:txBody>
                     <a:bodyPr/>
@@ -7971,7 +7971,7 @@
                           </a:solidFill>
                           <a:latin typeface="Segoe UI"/>
                         </a:rPr>
-                        <a:t>Memoria mappe (byte)</a:t>
+                        <a:t>Map lookup / pkt (stima)</a:t>
                       </a:r>
                     </a:p>
                   </a:txBody>
@@ -7994,7 +7994,7 @@
                           </a:solidFill>
                           <a:latin typeface="Consolas"/>
                         </a:rPr>
-                        <a:t>264</a:t>
+                        <a:t>8</a:t>
                       </a:r>
                     </a:p>
                   </a:txBody>
@@ -8017,7 +8017,7 @@
                           </a:solidFill>
                           <a:latin typeface="Consolas"/>
                         </a:rPr>
-                        <a:t>15 796</a:t>
+                        <a:t>322</a:t>
                       </a:r>
                     </a:p>
                   </a:txBody>
@@ -8040,7 +8040,7 @@
                           </a:solidFill>
                           <a:latin typeface="Consolas"/>
                         </a:rPr>
-                        <a:t>28 468</a:t>
+                        <a:t>384</a:t>
                       </a:r>
                     </a:p>
                   </a:txBody>
@@ -8051,7 +8051,7 @@
                   </a:tcPr>
                 </a:tc>
               </a:tr>
-              <a:tr h="422910">
+              <a:tr h="375920">
                 <a:tc>
                   <a:txBody>
                     <a:bodyPr/>
@@ -8065,7 +8065,7 @@
                           </a:solidFill>
                           <a:latin typeface="Segoe UI"/>
                         </a:rPr>
-                        <a:t>Latenza (ns / pkt)</a:t>
+                        <a:t>Memoria mappe (byte)</a:t>
                       </a:r>
                     </a:p>
                   </a:txBody>
@@ -8088,7 +8088,7 @@
                           </a:solidFill>
                           <a:latin typeface="Consolas"/>
                         </a:rPr>
-                        <a:t>1109.0</a:t>
+                        <a:t>264</a:t>
                       </a:r>
                     </a:p>
                   </a:txBody>
@@ -8111,7 +8111,7 @@
                           </a:solidFill>
                           <a:latin typeface="Consolas"/>
                         </a:rPr>
-                        <a:t>339.0</a:t>
+                        <a:t>15 796</a:t>
                       </a:r>
                     </a:p>
                   </a:txBody>
@@ -8134,7 +8134,7 @@
                           </a:solidFill>
                           <a:latin typeface="Consolas"/>
                         </a:rPr>
-                        <a:t>1291.0</a:t>
+                        <a:t>28 468</a:t>
                       </a:r>
                     </a:p>
                   </a:txBody>
@@ -8145,7 +8145,7 @@
                   </a:tcPr>
                 </a:tc>
               </a:tr>
-              <a:tr h="422910">
+              <a:tr h="375920">
                 <a:tc>
                   <a:txBody>
                     <a:bodyPr/>
@@ -8159,7 +8159,7 @@
                           </a:solidFill>
                           <a:latin typeface="Segoe UI"/>
                         </a:rPr>
-                        <a:t>Throughput (Mpps)</a:t>
+                        <a:t>Latenza (ns / pkt)</a:t>
                       </a:r>
                     </a:p>
                   </a:txBody>
@@ -8182,7 +8182,7 @@
                           </a:solidFill>
                           <a:latin typeface="Consolas"/>
                         </a:rPr>
-                        <a:t>0.902</a:t>
+                        <a:t>1109.0</a:t>
                       </a:r>
                     </a:p>
                   </a:txBody>
@@ -8205,7 +8205,7 @@
                           </a:solidFill>
                           <a:latin typeface="Consolas"/>
                         </a:rPr>
-                        <a:t>2.950</a:t>
+                        <a:t>339.0</a:t>
                       </a:r>
                     </a:p>
                   </a:txBody>
@@ -8228,7 +8228,7 @@
                           </a:solidFill>
                           <a:latin typeface="Consolas"/>
                         </a:rPr>
-                        <a:t>0.775</a:t>
+                        <a:t>1291.0</a:t>
                       </a:r>
                     </a:p>
                   </a:txBody>
@@ -8239,7 +8239,7 @@
                   </a:tcPr>
                 </a:tc>
               </a:tr>
-              <a:tr h="422910">
+              <a:tr h="375920">
                 <a:tc>
                   <a:txBody>
                     <a:bodyPr/>
@@ -8253,7 +8253,7 @@
                           </a:solidFill>
                           <a:latin typeface="Segoe UI"/>
                         </a:rPr>
-                        <a:t>CPU (%)</a:t>
+                        <a:t>Throughput (Mpps)</a:t>
                       </a:r>
                     </a:p>
                   </a:txBody>
@@ -8276,7 +8276,7 @@
                           </a:solidFill>
                           <a:latin typeface="Consolas"/>
                         </a:rPr>
-                        <a:t>60</a:t>
+                        <a:t>0.902</a:t>
                       </a:r>
                     </a:p>
                   </a:txBody>
@@ -8299,7 +8299,7 @@
                           </a:solidFill>
                           <a:latin typeface="Consolas"/>
                         </a:rPr>
-                        <a:t>48</a:t>
+                        <a:t>2.950</a:t>
                       </a:r>
                     </a:p>
                   </a:txBody>
@@ -8322,13 +8322,107 @@
                           </a:solidFill>
                           <a:latin typeface="Consolas"/>
                         </a:rPr>
+                        <a:t>0.775</a:t>
+                      </a:r>
+                    </a:p>
+                  </a:txBody>
+                  <a:tcPr marL="109728" marR="73152" marT="18288" marB="18288" anchor="ctr">
+                    <a:solidFill>
+                      <a:srgbClr val="1B222E"/>
+                    </a:solidFill>
+                  </a:tcPr>
+                </a:tc>
+              </a:tr>
+              <a:tr h="375920">
+                <a:tc>
+                  <a:txBody>
+                    <a:bodyPr/>
+                    <a:lstStyle/>
+                    <a:p>
+                      <a:pPr algn="l"/>
+                      <a:r>
+                        <a:rPr sz="1250" b="1">
+                          <a:solidFill>
+                            <a:srgbClr val="E6EDF3"/>
+                          </a:solidFill>
+                          <a:latin typeface="Segoe UI"/>
+                        </a:rPr>
+                        <a:t>CPU (%)</a:t>
+                      </a:r>
+                    </a:p>
+                  </a:txBody>
+                  <a:tcPr marL="109728" marR="73152" marT="18288" marB="18288" anchor="ctr">
+                    <a:solidFill>
+                      <a:srgbClr val="0D1117"/>
+                    </a:solidFill>
+                  </a:tcPr>
+                </a:tc>
+                <a:tc>
+                  <a:txBody>
+                    <a:bodyPr/>
+                    <a:lstStyle/>
+                    <a:p>
+                      <a:pPr algn="r"/>
+                      <a:r>
+                        <a:rPr sz="1250" b="0">
+                          <a:solidFill>
+                            <a:srgbClr val="E6EDF3"/>
+                          </a:solidFill>
+                          <a:latin typeface="Consolas"/>
+                        </a:rPr>
+                        <a:t>60</a:t>
+                      </a:r>
+                    </a:p>
+                  </a:txBody>
+                  <a:tcPr marL="109728" marR="73152" marT="18288" marB="18288" anchor="ctr">
+                    <a:solidFill>
+                      <a:srgbClr val="0D1117"/>
+                    </a:solidFill>
+                  </a:tcPr>
+                </a:tc>
+                <a:tc>
+                  <a:txBody>
+                    <a:bodyPr/>
+                    <a:lstStyle/>
+                    <a:p>
+                      <a:pPr algn="r"/>
+                      <a:r>
+                        <a:rPr sz="1250" b="0">
+                          <a:solidFill>
+                            <a:srgbClr val="E6EDF3"/>
+                          </a:solidFill>
+                          <a:latin typeface="Consolas"/>
+                        </a:rPr>
+                        <a:t>48</a:t>
+                      </a:r>
+                    </a:p>
+                  </a:txBody>
+                  <a:tcPr marL="109728" marR="73152" marT="18288" marB="18288" anchor="ctr">
+                    <a:solidFill>
+                      <a:srgbClr val="0D1117"/>
+                    </a:solidFill>
+                  </a:tcPr>
+                </a:tc>
+                <a:tc>
+                  <a:txBody>
+                    <a:bodyPr/>
+                    <a:lstStyle/>
+                    <a:p>
+                      <a:pPr algn="r"/>
+                      <a:r>
+                        <a:rPr sz="1250" b="0">
+                          <a:solidFill>
+                            <a:srgbClr val="E6EDF3"/>
+                          </a:solidFill>
+                          <a:latin typeface="Consolas"/>
+                        </a:rPr>
                         <a:t>79</a:t>
                       </a:r>
                     </a:p>
                   </a:txBody>
                   <a:tcPr marL="109728" marR="73152" marT="18288" marB="18288" anchor="ctr">
                     <a:solidFill>
-                      <a:srgbClr val="1B222E"/>
+                      <a:srgbClr val="0D1117"/>
                     </a:solidFill>
                   </a:tcPr>
                 </a:tc>

</xml_diff>

<commit_message>
Finalize kernel metrics; hoist P2 link_state read out of the neuron loop
- Update all results tables (HTML, testing.md, 17-slide deck) with the re-run
  numbers after removing P1's per-packet printk: P1 now 72 ns / 13.9 Mpps / 996
  instr -- fastest, most compact, fewest lookups. Ordering P1<P2<P3 matches the
  taxonomy on every cost metric. Drop the stale 'P2 fastest' framing.
- P2 template: read link_state[0..5] once into locals before the neuron loop
  instead of re-looking-up inside it (was 6*N_H1=24 lookups, now 6). Pure
  fairness/efficiency cleanup; inference result unchanged.
- Document that the MLP inference is identical across pipelines (verified by the
  key-equivalence check) and that P1's lighter action (direct switch->redirect,
  no fwd_table lookup / MAC rewrite) is a design choice, not hidden work.
</commit_message>
<xml_diff>
--- a/docs/IPA_eBPF_pipelines.pptx
+++ b/docs/IPA_eBPF_pipelines.pptx
@@ -7712,7 +7712,7 @@
                           </a:solidFill>
                           <a:latin typeface="Consolas"/>
                         </a:rPr>
-                        <a:t>1 095</a:t>
+                        <a:t>996</a:t>
                       </a:r>
                     </a:p>
                   </a:txBody>
@@ -7806,7 +7806,7 @@
                           </a:solidFill>
                           <a:latin typeface="Consolas"/>
                         </a:rPr>
-                        <a:t>5 132</a:t>
+                        <a:t>4 658</a:t>
                       </a:r>
                     </a:p>
                   </a:txBody>
@@ -8182,7 +8182,7 @@
                           </a:solidFill>
                           <a:latin typeface="Consolas"/>
                         </a:rPr>
-                        <a:t>1109.0</a:t>
+                        <a:t>72.0</a:t>
                       </a:r>
                     </a:p>
                   </a:txBody>
@@ -8205,7 +8205,7 @@
                           </a:solidFill>
                           <a:latin typeface="Consolas"/>
                         </a:rPr>
-                        <a:t>339.0</a:t>
+                        <a:t>287.0</a:t>
                       </a:r>
                     </a:p>
                   </a:txBody>
@@ -8228,7 +8228,7 @@
                           </a:solidFill>
                           <a:latin typeface="Consolas"/>
                         </a:rPr>
-                        <a:t>1291.0</a:t>
+                        <a:t>1274.0</a:t>
                       </a:r>
                     </a:p>
                   </a:txBody>
@@ -8276,7 +8276,7 @@
                           </a:solidFill>
                           <a:latin typeface="Consolas"/>
                         </a:rPr>
-                        <a:t>0.902</a:t>
+                        <a:t>13.889</a:t>
                       </a:r>
                     </a:p>
                   </a:txBody>
@@ -8299,7 +8299,7 @@
                           </a:solidFill>
                           <a:latin typeface="Consolas"/>
                         </a:rPr>
-                        <a:t>2.950</a:t>
+                        <a:t>3.484</a:t>
                       </a:r>
                     </a:p>
                   </a:txBody>
@@ -8322,7 +8322,7 @@
                           </a:solidFill>
                           <a:latin typeface="Consolas"/>
                         </a:rPr>
-                        <a:t>0.775</a:t>
+                        <a:t>0.785</a:t>
                       </a:r>
                     </a:p>
                   </a:txBody>
@@ -8370,7 +8370,7 @@
                           </a:solidFill>
                           <a:latin typeface="Consolas"/>
                         </a:rPr>
-                        <a:t>60</a:t>
+                        <a:t>58</a:t>
                       </a:r>
                     </a:p>
                   </a:txBody>
@@ -8393,7 +8393,7 @@
                           </a:solidFill>
                           <a:latin typeface="Consolas"/>
                         </a:rPr>
-                        <a:t>48</a:t>
+                        <a:t>61</a:t>
                       </a:r>
                     </a:p>
                   </a:txBody>
@@ -8416,7 +8416,7 @@
                           </a:solidFill>
                           <a:latin typeface="Consolas"/>
                         </a:rPr>
-                        <a:t>79</a:t>
+                        <a:t>80</a:t>
                       </a:r>
                     </a:p>
                   </a:txBody>
@@ -8548,7 +8548,7 @@
                 </a:solidFill>
                 <a:latin typeface="Segoe UI"/>
               </a:rPr>
-              <a:t>P2 più veloce (339 ns).</a:t>
+              <a:t>P1 più veloce: 72 ns, 13.9 Mpps.</a:t>
             </a:r>
           </a:p>
           <a:p>
@@ -8579,7 +8579,38 @@
                 </a:solidFill>
                 <a:latin typeface="Segoe UI"/>
               </a:rPr>
-              <a:t>P1 hardcoded puro: solo 264 B di mappe.</a:t>
+              <a:t>P1 più compatto: 264 B, 996 istr.</a:t>
+            </a:r>
+          </a:p>
+          <a:p>
+            <a:pPr algn="l">
+              <a:lnSpc>
+                <a:spcPct val="105000"/>
+              </a:lnSpc>
+              <a:spcBef>
+                <a:spcPts val="0"/>
+              </a:spcBef>
+              <a:spcAft>
+                <a:spcPts val="500"/>
+              </a:spcAft>
+            </a:pPr>
+            <a:r>
+              <a:rPr sz="1100" b="0">
+                <a:solidFill>
+                  <a:srgbClr val="3FD0C8"/>
+                </a:solidFill>
+                <a:latin typeface="Segoe UI"/>
+              </a:rPr>
+              <a:t>•  </a:t>
+            </a:r>
+            <a:r>
+              <a:rPr sz="1100" b="0">
+                <a:solidFill>
+                  <a:srgbClr val="8B949E"/>
+                </a:solidFill>
+                <a:latin typeface="Segoe UI"/>
+              </a:rPr>
+              <a:t>Ogni costo cresce P1→P2→P3.</a:t>
             </a:r>
           </a:p>
           <a:p>
@@ -8655,7 +8686,7 @@
                 </a:solidFill>
                 <a:latin typeface="Segoe UI"/>
               </a:rPr>
-              <a:t>Misurato dopo link_state reale + rimozione di model_cache: </a:t>
+              <a:t>Confronto pulito: </a:t>
             </a:r>
             <a:r>
               <a:rPr sz="1200" b="0">
@@ -8664,7 +8695,7 @@
                 </a:solidFill>
                 <a:latin typeface="Segoe UI"/>
               </a:rPr>
-              <a:t>la memoria mappe di P1 crolla da 83 KB a 264 B (model_cache era il 99%); il popolamento link_state costa +38 istruzioni su P1, +~930 su P2. Latenza/throughput hanno varianza run-to-run.</a:t>
+              <a:t>P1 è sceso da 1109 a 72 ns rimuovendo 3 bpf_trace_printk per pacchetto (assenti in P2/P3) che falsavano il baseline. L'inferenza è identica nelle 3 (chiave kernel = riferimento Python); differisce solo il design. Ordine coerente con la tassonomia.</a:t>
             </a:r>
           </a:p>
         </p:txBody>
@@ -10955,7 +10986,7 @@
                 </a:solidFill>
                 <a:latin typeface="Segoe UI"/>
               </a:rPr>
-              <a:t>Il più veloce nei nostri test</a:t>
+              <a:t>Prestazioni intermedie (287 ns)</a:t>
             </a:r>
           </a:p>
           <a:p>
@@ -19748,7 +19779,7 @@
                 </a:solidFill>
                 <a:latin typeface="Segoe UI"/>
               </a:rPr>
-              <a:t>Il risultato controintuitivo: il template è anche il più veloce.</a:t>
+              <a:t>Prestazioni intermedie (287 ns): tra P1 hardcoded e P3 modular.</a:t>
             </a:r>
           </a:p>
         </p:txBody>

</xml_diff>

<commit_message>
docs: polish pipeline diagrams (HTML + deck)
- Redesign the HTML pipeline flow diagrams: horizontal node-based layout with
  colored top-accent bars, mono type labels, labelled chevron connectors, and a
  per-pipeline 'cost strip' of pills (tail calls / weight lookups / map memory /
  latency) that makes the perf-vs-flexibility trade-off visible at a glance
  (P1 all-green, P3 all-red).
- Deck: add top-accent bars to pipeline nodes and a matching cost strip under
  each of the three pipeline slides.
</commit_message>
<xml_diff>
--- a/docs/IPA_eBPF_pipelines.pptx
+++ b/docs/IPA_eBPF_pipelines.pptx
@@ -3861,14 +3861,58 @@
       </p:sp>
       <p:sp>
         <p:nvSpPr>
-          <p:cNvPr id="7" name="TextBox 6"/>
+          <p:cNvPr id="7" name="Rounded Rectangle 6"/>
+          <p:cNvSpPr/>
+          <p:nvPr/>
+        </p:nvSpPr>
+        <p:spPr>
+          <a:xfrm>
+            <a:off x="731519" y="2194560"/>
+            <a:ext cx="1691640" cy="64008"/>
+          </a:xfrm>
+          <a:prstGeom prst="roundRect">
+            <a:avLst/>
+          </a:prstGeom>
+          <a:solidFill>
+            <a:srgbClr val="E6EDF3"/>
+          </a:solidFill>
+          <a:ln>
+            <a:noFill/>
+          </a:ln>
+          <a:effectLst/>
+        </p:spPr>
+        <p:style>
+          <a:lnRef idx="1">
+            <a:schemeClr val="accent1"/>
+          </a:lnRef>
+          <a:fillRef idx="3">
+            <a:schemeClr val="accent1"/>
+          </a:fillRef>
+          <a:effectRef idx="2">
+            <a:schemeClr val="accent1"/>
+          </a:effectRef>
+          <a:fontRef idx="minor">
+            <a:schemeClr val="lt1"/>
+          </a:fontRef>
+        </p:style>
+        <p:txBody>
+          <a:bodyPr rtlCol="0" anchor="ctr"/>
+          <a:lstStyle/>
+          <a:p>
+            <a:pPr algn="ctr"/>
+          </a:p>
+        </p:txBody>
+      </p:sp>
+      <p:sp>
+        <p:nvSpPr>
+          <p:cNvPr id="8" name="TextBox 7"/>
           <p:cNvSpPr txBox="1"/>
           <p:nvPr/>
         </p:nvSpPr>
         <p:spPr>
           <a:xfrm>
-            <a:off x="713231" y="2148840"/>
-            <a:ext cx="1728216" cy="1051560"/>
+            <a:off x="713231" y="2203704"/>
+            <a:ext cx="1728216" cy="996695"/>
           </a:xfrm>
           <a:prstGeom prst="rect">
             <a:avLst/>
@@ -3928,7 +3972,7 @@
       </p:sp>
       <p:sp>
         <p:nvSpPr>
-          <p:cNvPr id="8" name="TextBox 7"/>
+          <p:cNvPr id="9" name="TextBox 8"/>
           <p:cNvSpPr txBox="1"/>
           <p:nvPr/>
         </p:nvSpPr>
@@ -3973,7 +4017,7 @@
       </p:sp>
       <p:sp>
         <p:nvSpPr>
-          <p:cNvPr id="9" name="Rounded Rectangle 8"/>
+          <p:cNvPr id="10" name="Rounded Rectangle 9"/>
           <p:cNvSpPr/>
           <p:nvPr/>
         </p:nvSpPr>
@@ -4019,14 +4063,58 @@
       </p:sp>
       <p:sp>
         <p:nvSpPr>
-          <p:cNvPr id="10" name="TextBox 9"/>
+          <p:cNvPr id="11" name="Rounded Rectangle 10"/>
+          <p:cNvSpPr/>
+          <p:nvPr/>
+        </p:nvSpPr>
+        <p:spPr>
+          <a:xfrm>
+            <a:off x="2990088" y="2194560"/>
+            <a:ext cx="1691640" cy="64008"/>
+          </a:xfrm>
+          <a:prstGeom prst="roundRect">
+            <a:avLst/>
+          </a:prstGeom>
+          <a:solidFill>
+            <a:srgbClr val="F85149"/>
+          </a:solidFill>
+          <a:ln>
+            <a:noFill/>
+          </a:ln>
+          <a:effectLst/>
+        </p:spPr>
+        <p:style>
+          <a:lnRef idx="1">
+            <a:schemeClr val="accent1"/>
+          </a:lnRef>
+          <a:fillRef idx="3">
+            <a:schemeClr val="accent1"/>
+          </a:fillRef>
+          <a:effectRef idx="2">
+            <a:schemeClr val="accent1"/>
+          </a:effectRef>
+          <a:fontRef idx="minor">
+            <a:schemeClr val="lt1"/>
+          </a:fontRef>
+        </p:style>
+        <p:txBody>
+          <a:bodyPr rtlCol="0" anchor="ctr"/>
+          <a:lstStyle/>
+          <a:p>
+            <a:pPr algn="ctr"/>
+          </a:p>
+        </p:txBody>
+      </p:sp>
+      <p:sp>
+        <p:nvSpPr>
+          <p:cNvPr id="12" name="TextBox 11"/>
           <p:cNvSpPr txBox="1"/>
           <p:nvPr/>
         </p:nvSpPr>
         <p:spPr>
           <a:xfrm>
-            <a:off x="2971800" y="2148840"/>
-            <a:ext cx="1728216" cy="1051560"/>
+            <a:off x="2971800" y="2203704"/>
+            <a:ext cx="1728216" cy="996695"/>
           </a:xfrm>
           <a:prstGeom prst="rect">
             <a:avLst/>
@@ -4086,7 +4174,7 @@
       </p:sp>
       <p:sp>
         <p:nvSpPr>
-          <p:cNvPr id="11" name="TextBox 10"/>
+          <p:cNvPr id="13" name="TextBox 12"/>
           <p:cNvSpPr txBox="1"/>
           <p:nvPr/>
         </p:nvSpPr>
@@ -4131,7 +4219,7 @@
       </p:sp>
       <p:sp>
         <p:nvSpPr>
-          <p:cNvPr id="12" name="Rounded Rectangle 11"/>
+          <p:cNvPr id="14" name="Rounded Rectangle 13"/>
           <p:cNvSpPr/>
           <p:nvPr/>
         </p:nvSpPr>
@@ -4177,14 +4265,58 @@
       </p:sp>
       <p:sp>
         <p:nvSpPr>
-          <p:cNvPr id="13" name="TextBox 12"/>
+          <p:cNvPr id="15" name="Rounded Rectangle 14"/>
+          <p:cNvSpPr/>
+          <p:nvPr/>
+        </p:nvSpPr>
+        <p:spPr>
+          <a:xfrm>
+            <a:off x="5248656" y="2194560"/>
+            <a:ext cx="1691640" cy="64008"/>
+          </a:xfrm>
+          <a:prstGeom prst="roundRect">
+            <a:avLst/>
+          </a:prstGeom>
+          <a:solidFill>
+            <a:srgbClr val="F85149"/>
+          </a:solidFill>
+          <a:ln>
+            <a:noFill/>
+          </a:ln>
+          <a:effectLst/>
+        </p:spPr>
+        <p:style>
+          <a:lnRef idx="1">
+            <a:schemeClr val="accent1"/>
+          </a:lnRef>
+          <a:fillRef idx="3">
+            <a:schemeClr val="accent1"/>
+          </a:fillRef>
+          <a:effectRef idx="2">
+            <a:schemeClr val="accent1"/>
+          </a:effectRef>
+          <a:fontRef idx="minor">
+            <a:schemeClr val="lt1"/>
+          </a:fontRef>
+        </p:style>
+        <p:txBody>
+          <a:bodyPr rtlCol="0" anchor="ctr"/>
+          <a:lstStyle/>
+          <a:p>
+            <a:pPr algn="ctr"/>
+          </a:p>
+        </p:txBody>
+      </p:sp>
+      <p:sp>
+        <p:nvSpPr>
+          <p:cNvPr id="16" name="TextBox 15"/>
           <p:cNvSpPr txBox="1"/>
           <p:nvPr/>
         </p:nvSpPr>
         <p:spPr>
           <a:xfrm>
-            <a:off x="5230368" y="2148840"/>
-            <a:ext cx="1728216" cy="1051560"/>
+            <a:off x="5230368" y="2203704"/>
+            <a:ext cx="1728216" cy="996695"/>
           </a:xfrm>
           <a:prstGeom prst="rect">
             <a:avLst/>
@@ -4244,7 +4376,7 @@
       </p:sp>
       <p:sp>
         <p:nvSpPr>
-          <p:cNvPr id="14" name="TextBox 13"/>
+          <p:cNvPr id="17" name="TextBox 16"/>
           <p:cNvSpPr txBox="1"/>
           <p:nvPr/>
         </p:nvSpPr>
@@ -4289,7 +4421,7 @@
       </p:sp>
       <p:sp>
         <p:nvSpPr>
-          <p:cNvPr id="15" name="Rounded Rectangle 14"/>
+          <p:cNvPr id="18" name="Rounded Rectangle 17"/>
           <p:cNvSpPr/>
           <p:nvPr/>
         </p:nvSpPr>
@@ -4335,14 +4467,58 @@
       </p:sp>
       <p:sp>
         <p:nvSpPr>
-          <p:cNvPr id="16" name="TextBox 15"/>
+          <p:cNvPr id="19" name="Rounded Rectangle 18"/>
+          <p:cNvSpPr/>
+          <p:nvPr/>
+        </p:nvSpPr>
+        <p:spPr>
+          <a:xfrm>
+            <a:off x="7507224" y="2194560"/>
+            <a:ext cx="1691640" cy="64008"/>
+          </a:xfrm>
+          <a:prstGeom prst="roundRect">
+            <a:avLst/>
+          </a:prstGeom>
+          <a:solidFill>
+            <a:srgbClr val="F85149"/>
+          </a:solidFill>
+          <a:ln>
+            <a:noFill/>
+          </a:ln>
+          <a:effectLst/>
+        </p:spPr>
+        <p:style>
+          <a:lnRef idx="1">
+            <a:schemeClr val="accent1"/>
+          </a:lnRef>
+          <a:fillRef idx="3">
+            <a:schemeClr val="accent1"/>
+          </a:fillRef>
+          <a:effectRef idx="2">
+            <a:schemeClr val="accent1"/>
+          </a:effectRef>
+          <a:fontRef idx="minor">
+            <a:schemeClr val="lt1"/>
+          </a:fontRef>
+        </p:style>
+        <p:txBody>
+          <a:bodyPr rtlCol="0" anchor="ctr"/>
+          <a:lstStyle/>
+          <a:p>
+            <a:pPr algn="ctr"/>
+          </a:p>
+        </p:txBody>
+      </p:sp>
+      <p:sp>
+        <p:nvSpPr>
+          <p:cNvPr id="20" name="TextBox 19"/>
           <p:cNvSpPr txBox="1"/>
           <p:nvPr/>
         </p:nvSpPr>
         <p:spPr>
           <a:xfrm>
-            <a:off x="7488936" y="2148840"/>
-            <a:ext cx="1728216" cy="1051560"/>
+            <a:off x="7488936" y="2203704"/>
+            <a:ext cx="1728216" cy="996695"/>
           </a:xfrm>
           <a:prstGeom prst="rect">
             <a:avLst/>
@@ -4402,7 +4578,7 @@
       </p:sp>
       <p:sp>
         <p:nvSpPr>
-          <p:cNvPr id="17" name="TextBox 16"/>
+          <p:cNvPr id="21" name="TextBox 20"/>
           <p:cNvSpPr txBox="1"/>
           <p:nvPr/>
         </p:nvSpPr>
@@ -4447,7 +4623,7 @@
       </p:sp>
       <p:sp>
         <p:nvSpPr>
-          <p:cNvPr id="18" name="Rounded Rectangle 17"/>
+          <p:cNvPr id="22" name="Rounded Rectangle 21"/>
           <p:cNvSpPr/>
           <p:nvPr/>
         </p:nvSpPr>
@@ -4493,14 +4669,58 @@
       </p:sp>
       <p:sp>
         <p:nvSpPr>
-          <p:cNvPr id="19" name="TextBox 18"/>
+          <p:cNvPr id="23" name="Rounded Rectangle 22"/>
+          <p:cNvSpPr/>
+          <p:nvPr/>
+        </p:nvSpPr>
+        <p:spPr>
+          <a:xfrm>
+            <a:off x="9765792" y="2194560"/>
+            <a:ext cx="1691640" cy="64008"/>
+          </a:xfrm>
+          <a:prstGeom prst="roundRect">
+            <a:avLst/>
+          </a:prstGeom>
+          <a:solidFill>
+            <a:srgbClr val="3FD0C8"/>
+          </a:solidFill>
+          <a:ln>
+            <a:noFill/>
+          </a:ln>
+          <a:effectLst/>
+        </p:spPr>
+        <p:style>
+          <a:lnRef idx="1">
+            <a:schemeClr val="accent1"/>
+          </a:lnRef>
+          <a:fillRef idx="3">
+            <a:schemeClr val="accent1"/>
+          </a:fillRef>
+          <a:effectRef idx="2">
+            <a:schemeClr val="accent1"/>
+          </a:effectRef>
+          <a:fontRef idx="minor">
+            <a:schemeClr val="lt1"/>
+          </a:fontRef>
+        </p:style>
+        <p:txBody>
+          <a:bodyPr rtlCol="0" anchor="ctr"/>
+          <a:lstStyle/>
+          <a:p>
+            <a:pPr algn="ctr"/>
+          </a:p>
+        </p:txBody>
+      </p:sp>
+      <p:sp>
+        <p:nvSpPr>
+          <p:cNvPr id="24" name="TextBox 23"/>
           <p:cNvSpPr txBox="1"/>
           <p:nvPr/>
         </p:nvSpPr>
         <p:spPr>
           <a:xfrm>
-            <a:off x="9747504" y="2148840"/>
-            <a:ext cx="1728216" cy="1051560"/>
+            <a:off x="9747504" y="2203704"/>
+            <a:ext cx="1728216" cy="996695"/>
           </a:xfrm>
           <a:prstGeom prst="rect">
             <a:avLst/>
@@ -4560,14 +4780,378 @@
       </p:sp>
       <p:sp>
         <p:nvSpPr>
-          <p:cNvPr id="20" name="Rounded Rectangle 19"/>
+          <p:cNvPr id="25" name="Rounded Rectangle 24"/>
           <p:cNvSpPr/>
           <p:nvPr/>
         </p:nvSpPr>
         <p:spPr>
           <a:xfrm>
-            <a:off x="640080" y="3794760"/>
-            <a:ext cx="10927080" cy="2331720"/>
+            <a:off x="1917039" y="3364992"/>
+            <a:ext cx="1563624" cy="384048"/>
+          </a:xfrm>
+          <a:prstGeom prst="roundRect">
+            <a:avLst/>
+          </a:prstGeom>
+          <a:solidFill>
+            <a:srgbClr val="161B22"/>
+          </a:solidFill>
+          <a:ln w="12700">
+            <a:solidFill>
+              <a:srgbClr val="30363D"/>
+            </a:solidFill>
+          </a:ln>
+          <a:effectLst/>
+        </p:spPr>
+        <p:style>
+          <a:lnRef idx="1">
+            <a:schemeClr val="accent1"/>
+          </a:lnRef>
+          <a:fillRef idx="3">
+            <a:schemeClr val="accent1"/>
+          </a:fillRef>
+          <a:effectRef idx="2">
+            <a:schemeClr val="accent1"/>
+          </a:effectRef>
+          <a:fontRef idx="minor">
+            <a:schemeClr val="lt1"/>
+          </a:fontRef>
+        </p:style>
+        <p:txBody>
+          <a:bodyPr rtlCol="0" anchor="ctr"/>
+          <a:lstStyle/>
+          <a:p>
+            <a:pPr algn="ctr"/>
+          </a:p>
+        </p:txBody>
+      </p:sp>
+      <p:sp>
+        <p:nvSpPr>
+          <p:cNvPr id="26" name="TextBox 25"/>
+          <p:cNvSpPr txBox="1"/>
+          <p:nvPr/>
+        </p:nvSpPr>
+        <p:spPr>
+          <a:xfrm>
+            <a:off x="1917039" y="3364992"/>
+            <a:ext cx="1563624" cy="384048"/>
+          </a:xfrm>
+          <a:prstGeom prst="rect">
+            <a:avLst/>
+          </a:prstGeom>
+          <a:noFill/>
+        </p:spPr>
+        <p:txBody>
+          <a:bodyPr wrap="square" anchor="ctr" lIns="0" rIns="0" tIns="0" bIns="0">
+            <a:spAutoFit/>
+          </a:bodyPr>
+          <a:lstStyle/>
+          <a:p>
+            <a:pPr algn="ctr">
+              <a:lnSpc>
+                <a:spcPct val="100000"/>
+              </a:lnSpc>
+              <a:spcBef>
+                <a:spcPts val="0"/>
+              </a:spcBef>
+              <a:spcAft>
+                <a:spcPts val="200"/>
+              </a:spcAft>
+            </a:pPr>
+            <a:r>
+              <a:rPr sz="1100" b="1">
+                <a:solidFill>
+                  <a:srgbClr val="F85149"/>
+                </a:solidFill>
+                <a:latin typeface="Consolas"/>
+              </a:rPr>
+              <a:t>3 tail call</a:t>
+            </a:r>
+          </a:p>
+        </p:txBody>
+      </p:sp>
+      <p:sp>
+        <p:nvSpPr>
+          <p:cNvPr id="27" name="Rounded Rectangle 26"/>
+          <p:cNvSpPr/>
+          <p:nvPr/>
+        </p:nvSpPr>
+        <p:spPr>
+          <a:xfrm>
+            <a:off x="3645255" y="3364992"/>
+            <a:ext cx="2167128" cy="384048"/>
+          </a:xfrm>
+          <a:prstGeom prst="roundRect">
+            <a:avLst/>
+          </a:prstGeom>
+          <a:solidFill>
+            <a:srgbClr val="161B22"/>
+          </a:solidFill>
+          <a:ln w="12700">
+            <a:solidFill>
+              <a:srgbClr val="30363D"/>
+            </a:solidFill>
+          </a:ln>
+          <a:effectLst/>
+        </p:spPr>
+        <p:style>
+          <a:lnRef idx="1">
+            <a:schemeClr val="accent1"/>
+          </a:lnRef>
+          <a:fillRef idx="3">
+            <a:schemeClr val="accent1"/>
+          </a:fillRef>
+          <a:effectRef idx="2">
+            <a:schemeClr val="accent1"/>
+          </a:effectRef>
+          <a:fontRef idx="minor">
+            <a:schemeClr val="lt1"/>
+          </a:fontRef>
+        </p:style>
+        <p:txBody>
+          <a:bodyPr rtlCol="0" anchor="ctr"/>
+          <a:lstStyle/>
+          <a:p>
+            <a:pPr algn="ctr"/>
+          </a:p>
+        </p:txBody>
+      </p:sp>
+      <p:sp>
+        <p:nvSpPr>
+          <p:cNvPr id="28" name="TextBox 27"/>
+          <p:cNvSpPr txBox="1"/>
+          <p:nvPr/>
+        </p:nvSpPr>
+        <p:spPr>
+          <a:xfrm>
+            <a:off x="3645255" y="3364992"/>
+            <a:ext cx="2167128" cy="384048"/>
+          </a:xfrm>
+          <a:prstGeom prst="rect">
+            <a:avLst/>
+          </a:prstGeom>
+          <a:noFill/>
+        </p:spPr>
+        <p:txBody>
+          <a:bodyPr wrap="square" anchor="ctr" lIns="0" rIns="0" tIns="0" bIns="0">
+            <a:spAutoFit/>
+          </a:bodyPr>
+          <a:lstStyle/>
+          <a:p>
+            <a:pPr algn="ctr">
+              <a:lnSpc>
+                <a:spcPct val="100000"/>
+              </a:lnSpc>
+              <a:spcBef>
+                <a:spcPts val="0"/>
+              </a:spcBef>
+              <a:spcAft>
+                <a:spcPts val="200"/>
+              </a:spcAft>
+            </a:pPr>
+            <a:r>
+              <a:rPr sz="1100" b="1">
+                <a:solidFill>
+                  <a:srgbClr val="F85149"/>
+                </a:solidFill>
+                <a:latin typeface="Consolas"/>
+              </a:rPr>
+              <a:t>~384 lookup / pkt</a:t>
+            </a:r>
+          </a:p>
+        </p:txBody>
+      </p:sp>
+      <p:sp>
+        <p:nvSpPr>
+          <p:cNvPr id="29" name="Rounded Rectangle 28"/>
+          <p:cNvSpPr/>
+          <p:nvPr/>
+        </p:nvSpPr>
+        <p:spPr>
+          <a:xfrm>
+            <a:off x="5976975" y="3364992"/>
+            <a:ext cx="1764792" cy="384048"/>
+          </a:xfrm>
+          <a:prstGeom prst="roundRect">
+            <a:avLst/>
+          </a:prstGeom>
+          <a:solidFill>
+            <a:srgbClr val="161B22"/>
+          </a:solidFill>
+          <a:ln w="12700">
+            <a:solidFill>
+              <a:srgbClr val="30363D"/>
+            </a:solidFill>
+          </a:ln>
+          <a:effectLst/>
+        </p:spPr>
+        <p:style>
+          <a:lnRef idx="1">
+            <a:schemeClr val="accent1"/>
+          </a:lnRef>
+          <a:fillRef idx="3">
+            <a:schemeClr val="accent1"/>
+          </a:fillRef>
+          <a:effectRef idx="2">
+            <a:schemeClr val="accent1"/>
+          </a:effectRef>
+          <a:fontRef idx="minor">
+            <a:schemeClr val="lt1"/>
+          </a:fontRef>
+        </p:style>
+        <p:txBody>
+          <a:bodyPr rtlCol="0" anchor="ctr"/>
+          <a:lstStyle/>
+          <a:p>
+            <a:pPr algn="ctr"/>
+          </a:p>
+        </p:txBody>
+      </p:sp>
+      <p:sp>
+        <p:nvSpPr>
+          <p:cNvPr id="30" name="TextBox 29"/>
+          <p:cNvSpPr txBox="1"/>
+          <p:nvPr/>
+        </p:nvSpPr>
+        <p:spPr>
+          <a:xfrm>
+            <a:off x="5976975" y="3364992"/>
+            <a:ext cx="1764792" cy="384048"/>
+          </a:xfrm>
+          <a:prstGeom prst="rect">
+            <a:avLst/>
+          </a:prstGeom>
+          <a:noFill/>
+        </p:spPr>
+        <p:txBody>
+          <a:bodyPr wrap="square" anchor="ctr" lIns="0" rIns="0" tIns="0" bIns="0">
+            <a:spAutoFit/>
+          </a:bodyPr>
+          <a:lstStyle/>
+          <a:p>
+            <a:pPr algn="ctr">
+              <a:lnSpc>
+                <a:spcPct val="100000"/>
+              </a:lnSpc>
+              <a:spcBef>
+                <a:spcPts val="0"/>
+              </a:spcBef>
+              <a:spcAft>
+                <a:spcPts val="200"/>
+              </a:spcAft>
+            </a:pPr>
+            <a:r>
+              <a:rPr sz="1100" b="1">
+                <a:solidFill>
+                  <a:srgbClr val="E6EDF3"/>
+                </a:solidFill>
+                <a:latin typeface="Consolas"/>
+              </a:rPr>
+              <a:t>28.5 KB mappe</a:t>
+            </a:r>
+          </a:p>
+        </p:txBody>
+      </p:sp>
+      <p:sp>
+        <p:nvSpPr>
+          <p:cNvPr id="31" name="Rounded Rectangle 30"/>
+          <p:cNvSpPr/>
+          <p:nvPr/>
+        </p:nvSpPr>
+        <p:spPr>
+          <a:xfrm>
+            <a:off x="7906359" y="3364992"/>
+            <a:ext cx="2368296" cy="384048"/>
+          </a:xfrm>
+          <a:prstGeom prst="roundRect">
+            <a:avLst/>
+          </a:prstGeom>
+          <a:solidFill>
+            <a:srgbClr val="161B22"/>
+          </a:solidFill>
+          <a:ln w="12700">
+            <a:solidFill>
+              <a:srgbClr val="30363D"/>
+            </a:solidFill>
+          </a:ln>
+          <a:effectLst/>
+        </p:spPr>
+        <p:style>
+          <a:lnRef idx="1">
+            <a:schemeClr val="accent1"/>
+          </a:lnRef>
+          <a:fillRef idx="3">
+            <a:schemeClr val="accent1"/>
+          </a:fillRef>
+          <a:effectRef idx="2">
+            <a:schemeClr val="accent1"/>
+          </a:effectRef>
+          <a:fontRef idx="minor">
+            <a:schemeClr val="lt1"/>
+          </a:fontRef>
+        </p:style>
+        <p:txBody>
+          <a:bodyPr rtlCol="0" anchor="ctr"/>
+          <a:lstStyle/>
+          <a:p>
+            <a:pPr algn="ctr"/>
+          </a:p>
+        </p:txBody>
+      </p:sp>
+      <p:sp>
+        <p:nvSpPr>
+          <p:cNvPr id="32" name="TextBox 31"/>
+          <p:cNvSpPr txBox="1"/>
+          <p:nvPr/>
+        </p:nvSpPr>
+        <p:spPr>
+          <a:xfrm>
+            <a:off x="7906359" y="3364992"/>
+            <a:ext cx="2368296" cy="384048"/>
+          </a:xfrm>
+          <a:prstGeom prst="rect">
+            <a:avLst/>
+          </a:prstGeom>
+          <a:noFill/>
+        </p:spPr>
+        <p:txBody>
+          <a:bodyPr wrap="square" anchor="ctr" lIns="0" rIns="0" tIns="0" bIns="0">
+            <a:spAutoFit/>
+          </a:bodyPr>
+          <a:lstStyle/>
+          <a:p>
+            <a:pPr algn="ctr">
+              <a:lnSpc>
+                <a:spcPct val="100000"/>
+              </a:lnSpc>
+              <a:spcBef>
+                <a:spcPts val="0"/>
+              </a:spcBef>
+              <a:spcAft>
+                <a:spcPts val="200"/>
+              </a:spcAft>
+            </a:pPr>
+            <a:r>
+              <a:rPr sz="1100" b="1">
+                <a:solidFill>
+                  <a:srgbClr val="F85149"/>
+                </a:solidFill>
+                <a:latin typeface="Consolas"/>
+              </a:rPr>
+              <a:t>1274 ns · 0.79 Mpps</a:t>
+            </a:r>
+          </a:p>
+        </p:txBody>
+      </p:sp>
+      <p:sp>
+        <p:nvSpPr>
+          <p:cNvPr id="33" name="Rounded Rectangle 32"/>
+          <p:cNvSpPr/>
+          <p:nvPr/>
+        </p:nvSpPr>
+        <p:spPr>
+          <a:xfrm>
+            <a:off x="640080" y="3840480"/>
+            <a:ext cx="10927080" cy="2286000"/>
           </a:xfrm>
           <a:prstGeom prst="roundRect">
             <a:avLst/>
@@ -4606,14 +5190,14 @@
       </p:sp>
       <p:sp>
         <p:nvSpPr>
-          <p:cNvPr id="21" name="TextBox 20"/>
+          <p:cNvPr id="34" name="TextBox 33"/>
           <p:cNvSpPr txBox="1"/>
           <p:nvPr/>
         </p:nvSpPr>
         <p:spPr>
           <a:xfrm>
-            <a:off x="896112" y="3995928"/>
-            <a:ext cx="10469880" cy="1965960"/>
+            <a:off x="896112" y="4041648"/>
+            <a:ext cx="10469880" cy="1920240"/>
           </a:xfrm>
           <a:prstGeom prst="rect">
             <a:avLst/>
@@ -5838,14 +6422,58 @@
       </p:sp>
       <p:sp>
         <p:nvSpPr>
-          <p:cNvPr id="7" name="TextBox 6"/>
+          <p:cNvPr id="7" name="Rounded Rectangle 6"/>
+          <p:cNvSpPr/>
+          <p:nvPr/>
+        </p:nvSpPr>
+        <p:spPr>
+          <a:xfrm>
+            <a:off x="731519" y="2240279"/>
+            <a:ext cx="1691640" cy="64008"/>
+          </a:xfrm>
+          <a:prstGeom prst="roundRect">
+            <a:avLst/>
+          </a:prstGeom>
+          <a:solidFill>
+            <a:srgbClr val="58A6FF"/>
+          </a:solidFill>
+          <a:ln>
+            <a:noFill/>
+          </a:ln>
+          <a:effectLst/>
+        </p:spPr>
+        <p:style>
+          <a:lnRef idx="1">
+            <a:schemeClr val="accent1"/>
+          </a:lnRef>
+          <a:fillRef idx="3">
+            <a:schemeClr val="accent1"/>
+          </a:fillRef>
+          <a:effectRef idx="2">
+            <a:schemeClr val="accent1"/>
+          </a:effectRef>
+          <a:fontRef idx="minor">
+            <a:schemeClr val="lt1"/>
+          </a:fontRef>
+        </p:style>
+        <p:txBody>
+          <a:bodyPr rtlCol="0" anchor="ctr"/>
+          <a:lstStyle/>
+          <a:p>
+            <a:pPr algn="ctr"/>
+          </a:p>
+        </p:txBody>
+      </p:sp>
+      <p:sp>
+        <p:nvSpPr>
+          <p:cNvPr id="8" name="TextBox 7"/>
           <p:cNvSpPr txBox="1"/>
           <p:nvPr/>
         </p:nvSpPr>
         <p:spPr>
           <a:xfrm>
-            <a:off x="713231" y="2194560"/>
-            <a:ext cx="1728216" cy="1051560"/>
+            <a:off x="713231" y="2249424"/>
+            <a:ext cx="1728216" cy="996695"/>
           </a:xfrm>
           <a:prstGeom prst="rect">
             <a:avLst/>
@@ -5905,7 +6533,7 @@
       </p:sp>
       <p:sp>
         <p:nvSpPr>
-          <p:cNvPr id="8" name="TextBox 7"/>
+          <p:cNvPr id="9" name="TextBox 8"/>
           <p:cNvSpPr txBox="1"/>
           <p:nvPr/>
         </p:nvSpPr>
@@ -5950,7 +6578,7 @@
       </p:sp>
       <p:sp>
         <p:nvSpPr>
-          <p:cNvPr id="9" name="Rounded Rectangle 8"/>
+          <p:cNvPr id="10" name="Rounded Rectangle 9"/>
           <p:cNvSpPr/>
           <p:nvPr/>
         </p:nvSpPr>
@@ -5996,14 +6624,58 @@
       </p:sp>
       <p:sp>
         <p:nvSpPr>
-          <p:cNvPr id="10" name="TextBox 9"/>
+          <p:cNvPr id="11" name="Rounded Rectangle 10"/>
+          <p:cNvSpPr/>
+          <p:nvPr/>
+        </p:nvSpPr>
+        <p:spPr>
+          <a:xfrm>
+            <a:off x="2990088" y="2240279"/>
+            <a:ext cx="1691640" cy="64008"/>
+          </a:xfrm>
+          <a:prstGeom prst="roundRect">
+            <a:avLst/>
+          </a:prstGeom>
+          <a:solidFill>
+            <a:srgbClr val="E6EDF3"/>
+          </a:solidFill>
+          <a:ln>
+            <a:noFill/>
+          </a:ln>
+          <a:effectLst/>
+        </p:spPr>
+        <p:style>
+          <a:lnRef idx="1">
+            <a:schemeClr val="accent1"/>
+          </a:lnRef>
+          <a:fillRef idx="3">
+            <a:schemeClr val="accent1"/>
+          </a:fillRef>
+          <a:effectRef idx="2">
+            <a:schemeClr val="accent1"/>
+          </a:effectRef>
+          <a:fontRef idx="minor">
+            <a:schemeClr val="lt1"/>
+          </a:fontRef>
+        </p:style>
+        <p:txBody>
+          <a:bodyPr rtlCol="0" anchor="ctr"/>
+          <a:lstStyle/>
+          <a:p>
+            <a:pPr algn="ctr"/>
+          </a:p>
+        </p:txBody>
+      </p:sp>
+      <p:sp>
+        <p:nvSpPr>
+          <p:cNvPr id="12" name="TextBox 11"/>
           <p:cNvSpPr txBox="1"/>
           <p:nvPr/>
         </p:nvSpPr>
         <p:spPr>
           <a:xfrm>
-            <a:off x="2971800" y="2194560"/>
-            <a:ext cx="1728216" cy="1051560"/>
+            <a:off x="2971800" y="2249424"/>
+            <a:ext cx="1728216" cy="996695"/>
           </a:xfrm>
           <a:prstGeom prst="rect">
             <a:avLst/>
@@ -6063,7 +6735,7 @@
       </p:sp>
       <p:sp>
         <p:nvSpPr>
-          <p:cNvPr id="11" name="TextBox 10"/>
+          <p:cNvPr id="13" name="TextBox 12"/>
           <p:cNvSpPr txBox="1"/>
           <p:nvPr/>
         </p:nvSpPr>
@@ -6108,7 +6780,7 @@
       </p:sp>
       <p:sp>
         <p:nvSpPr>
-          <p:cNvPr id="12" name="Rounded Rectangle 11"/>
+          <p:cNvPr id="14" name="Rounded Rectangle 13"/>
           <p:cNvSpPr/>
           <p:nvPr/>
         </p:nvSpPr>
@@ -6154,14 +6826,58 @@
       </p:sp>
       <p:sp>
         <p:nvSpPr>
-          <p:cNvPr id="13" name="TextBox 12"/>
+          <p:cNvPr id="15" name="Rounded Rectangle 14"/>
+          <p:cNvSpPr/>
+          <p:nvPr/>
+        </p:nvSpPr>
+        <p:spPr>
+          <a:xfrm>
+            <a:off x="5248656" y="2240279"/>
+            <a:ext cx="1691640" cy="64008"/>
+          </a:xfrm>
+          <a:prstGeom prst="roundRect">
+            <a:avLst/>
+          </a:prstGeom>
+          <a:solidFill>
+            <a:srgbClr val="F5A623"/>
+          </a:solidFill>
+          <a:ln>
+            <a:noFill/>
+          </a:ln>
+          <a:effectLst/>
+        </p:spPr>
+        <p:style>
+          <a:lnRef idx="1">
+            <a:schemeClr val="accent1"/>
+          </a:lnRef>
+          <a:fillRef idx="3">
+            <a:schemeClr val="accent1"/>
+          </a:fillRef>
+          <a:effectRef idx="2">
+            <a:schemeClr val="accent1"/>
+          </a:effectRef>
+          <a:fontRef idx="minor">
+            <a:schemeClr val="lt1"/>
+          </a:fontRef>
+        </p:style>
+        <p:txBody>
+          <a:bodyPr rtlCol="0" anchor="ctr"/>
+          <a:lstStyle/>
+          <a:p>
+            <a:pPr algn="ctr"/>
+          </a:p>
+        </p:txBody>
+      </p:sp>
+      <p:sp>
+        <p:nvSpPr>
+          <p:cNvPr id="16" name="TextBox 15"/>
           <p:cNvSpPr txBox="1"/>
           <p:nvPr/>
         </p:nvSpPr>
         <p:spPr>
           <a:xfrm>
-            <a:off x="5230368" y="2194560"/>
-            <a:ext cx="1728216" cy="1051560"/>
+            <a:off x="5230368" y="2249424"/>
+            <a:ext cx="1728216" cy="996695"/>
           </a:xfrm>
           <a:prstGeom prst="rect">
             <a:avLst/>
@@ -6221,7 +6937,7 @@
       </p:sp>
       <p:sp>
         <p:nvSpPr>
-          <p:cNvPr id="14" name="TextBox 13"/>
+          <p:cNvPr id="17" name="TextBox 16"/>
           <p:cNvSpPr txBox="1"/>
           <p:nvPr/>
         </p:nvSpPr>
@@ -6266,7 +6982,7 @@
       </p:sp>
       <p:sp>
         <p:nvSpPr>
-          <p:cNvPr id="15" name="Rounded Rectangle 14"/>
+          <p:cNvPr id="18" name="Rounded Rectangle 17"/>
           <p:cNvSpPr/>
           <p:nvPr/>
         </p:nvSpPr>
@@ -6312,14 +7028,58 @@
       </p:sp>
       <p:sp>
         <p:nvSpPr>
-          <p:cNvPr id="16" name="TextBox 15"/>
+          <p:cNvPr id="19" name="Rounded Rectangle 18"/>
+          <p:cNvSpPr/>
+          <p:nvPr/>
+        </p:nvSpPr>
+        <p:spPr>
+          <a:xfrm>
+            <a:off x="7507224" y="2240279"/>
+            <a:ext cx="1691640" cy="64008"/>
+          </a:xfrm>
+          <a:prstGeom prst="roundRect">
+            <a:avLst/>
+          </a:prstGeom>
+          <a:solidFill>
+            <a:srgbClr val="E6EDF3"/>
+          </a:solidFill>
+          <a:ln>
+            <a:noFill/>
+          </a:ln>
+          <a:effectLst/>
+        </p:spPr>
+        <p:style>
+          <a:lnRef idx="1">
+            <a:schemeClr val="accent1"/>
+          </a:lnRef>
+          <a:fillRef idx="3">
+            <a:schemeClr val="accent1"/>
+          </a:fillRef>
+          <a:effectRef idx="2">
+            <a:schemeClr val="accent1"/>
+          </a:effectRef>
+          <a:fontRef idx="minor">
+            <a:schemeClr val="lt1"/>
+          </a:fontRef>
+        </p:style>
+        <p:txBody>
+          <a:bodyPr rtlCol="0" anchor="ctr"/>
+          <a:lstStyle/>
+          <a:p>
+            <a:pPr algn="ctr"/>
+          </a:p>
+        </p:txBody>
+      </p:sp>
+      <p:sp>
+        <p:nvSpPr>
+          <p:cNvPr id="20" name="TextBox 19"/>
           <p:cNvSpPr txBox="1"/>
           <p:nvPr/>
         </p:nvSpPr>
         <p:spPr>
           <a:xfrm>
-            <a:off x="7488936" y="2194560"/>
-            <a:ext cx="1728216" cy="1051560"/>
+            <a:off x="7488936" y="2249424"/>
+            <a:ext cx="1728216" cy="996695"/>
           </a:xfrm>
           <a:prstGeom prst="rect">
             <a:avLst/>
@@ -6379,7 +7139,7 @@
       </p:sp>
       <p:sp>
         <p:nvSpPr>
-          <p:cNvPr id="17" name="TextBox 16"/>
+          <p:cNvPr id="21" name="TextBox 20"/>
           <p:cNvSpPr txBox="1"/>
           <p:nvPr/>
         </p:nvSpPr>
@@ -6424,7 +7184,7 @@
       </p:sp>
       <p:sp>
         <p:nvSpPr>
-          <p:cNvPr id="18" name="Rounded Rectangle 17"/>
+          <p:cNvPr id="22" name="Rounded Rectangle 21"/>
           <p:cNvSpPr/>
           <p:nvPr/>
         </p:nvSpPr>
@@ -6470,14 +7230,58 @@
       </p:sp>
       <p:sp>
         <p:nvSpPr>
-          <p:cNvPr id="19" name="TextBox 18"/>
+          <p:cNvPr id="23" name="Rounded Rectangle 22"/>
+          <p:cNvSpPr/>
+          <p:nvPr/>
+        </p:nvSpPr>
+        <p:spPr>
+          <a:xfrm>
+            <a:off x="9765792" y="2240279"/>
+            <a:ext cx="1691640" cy="64008"/>
+          </a:xfrm>
+          <a:prstGeom prst="roundRect">
+            <a:avLst/>
+          </a:prstGeom>
+          <a:solidFill>
+            <a:srgbClr val="3FD0C8"/>
+          </a:solidFill>
+          <a:ln>
+            <a:noFill/>
+          </a:ln>
+          <a:effectLst/>
+        </p:spPr>
+        <p:style>
+          <a:lnRef idx="1">
+            <a:schemeClr val="accent1"/>
+          </a:lnRef>
+          <a:fillRef idx="3">
+            <a:schemeClr val="accent1"/>
+          </a:fillRef>
+          <a:effectRef idx="2">
+            <a:schemeClr val="accent1"/>
+          </a:effectRef>
+          <a:fontRef idx="minor">
+            <a:schemeClr val="lt1"/>
+          </a:fontRef>
+        </p:style>
+        <p:txBody>
+          <a:bodyPr rtlCol="0" anchor="ctr"/>
+          <a:lstStyle/>
+          <a:p>
+            <a:pPr algn="ctr"/>
+          </a:p>
+        </p:txBody>
+      </p:sp>
+      <p:sp>
+        <p:nvSpPr>
+          <p:cNvPr id="24" name="TextBox 23"/>
           <p:cNvSpPr txBox="1"/>
           <p:nvPr/>
         </p:nvSpPr>
         <p:spPr>
           <a:xfrm>
-            <a:off x="9747504" y="2194560"/>
-            <a:ext cx="1728216" cy="1051560"/>
+            <a:off x="9747504" y="2249424"/>
+            <a:ext cx="1728216" cy="996695"/>
           </a:xfrm>
           <a:prstGeom prst="rect">
             <a:avLst/>
@@ -6537,7 +7341,7 @@
       </p:sp>
       <p:sp>
         <p:nvSpPr>
-          <p:cNvPr id="20" name="Rounded Rectangle 19"/>
+          <p:cNvPr id="25" name="Rounded Rectangle 24"/>
           <p:cNvSpPr/>
           <p:nvPr/>
         </p:nvSpPr>
@@ -6583,7 +7387,7 @@
       </p:sp>
       <p:sp>
         <p:nvSpPr>
-          <p:cNvPr id="21" name="TextBox 20"/>
+          <p:cNvPr id="26" name="TextBox 25"/>
           <p:cNvSpPr txBox="1"/>
           <p:nvPr/>
         </p:nvSpPr>
@@ -6721,7 +7525,7 @@
       </p:sp>
       <p:sp>
         <p:nvSpPr>
-          <p:cNvPr id="22" name="Rounded Rectangle 21"/>
+          <p:cNvPr id="27" name="Rounded Rectangle 26"/>
           <p:cNvSpPr/>
           <p:nvPr/>
         </p:nvSpPr>
@@ -6767,7 +7571,7 @@
       </p:sp>
       <p:sp>
         <p:nvSpPr>
-          <p:cNvPr id="23" name="TextBox 22"/>
+          <p:cNvPr id="28" name="TextBox 27"/>
           <p:cNvSpPr txBox="1"/>
           <p:nvPr/>
         </p:nvSpPr>
@@ -12437,14 +13241,58 @@
       </p:sp>
       <p:sp>
         <p:nvSpPr>
-          <p:cNvPr id="7" name="TextBox 6"/>
+          <p:cNvPr id="7" name="Rounded Rectangle 6"/>
+          <p:cNvSpPr/>
+          <p:nvPr/>
+        </p:nvSpPr>
+        <p:spPr>
+          <a:xfrm>
+            <a:off x="731519" y="2194560"/>
+            <a:ext cx="1691640" cy="64008"/>
+          </a:xfrm>
+          <a:prstGeom prst="roundRect">
+            <a:avLst/>
+          </a:prstGeom>
+          <a:solidFill>
+            <a:srgbClr val="58A6FF"/>
+          </a:solidFill>
+          <a:ln>
+            <a:noFill/>
+          </a:ln>
+          <a:effectLst/>
+        </p:spPr>
+        <p:style>
+          <a:lnRef idx="1">
+            <a:schemeClr val="accent1"/>
+          </a:lnRef>
+          <a:fillRef idx="3">
+            <a:schemeClr val="accent1"/>
+          </a:fillRef>
+          <a:effectRef idx="2">
+            <a:schemeClr val="accent1"/>
+          </a:effectRef>
+          <a:fontRef idx="minor">
+            <a:schemeClr val="lt1"/>
+          </a:fontRef>
+        </p:style>
+        <p:txBody>
+          <a:bodyPr rtlCol="0" anchor="ctr"/>
+          <a:lstStyle/>
+          <a:p>
+            <a:pPr algn="ctr"/>
+          </a:p>
+        </p:txBody>
+      </p:sp>
+      <p:sp>
+        <p:nvSpPr>
+          <p:cNvPr id="8" name="TextBox 7"/>
           <p:cNvSpPr txBox="1"/>
           <p:nvPr/>
         </p:nvSpPr>
         <p:spPr>
           <a:xfrm>
-            <a:off x="713231" y="2148840"/>
-            <a:ext cx="1728216" cy="1051560"/>
+            <a:off x="713231" y="2203704"/>
+            <a:ext cx="1728216" cy="996695"/>
           </a:xfrm>
           <a:prstGeom prst="rect">
             <a:avLst/>
@@ -12504,7 +13352,7 @@
       </p:sp>
       <p:sp>
         <p:nvSpPr>
-          <p:cNvPr id="8" name="TextBox 7"/>
+          <p:cNvPr id="9" name="TextBox 8"/>
           <p:cNvSpPr txBox="1"/>
           <p:nvPr/>
         </p:nvSpPr>
@@ -12549,7 +13397,7 @@
       </p:sp>
       <p:sp>
         <p:nvSpPr>
-          <p:cNvPr id="9" name="Rounded Rectangle 8"/>
+          <p:cNvPr id="10" name="Rounded Rectangle 9"/>
           <p:cNvSpPr/>
           <p:nvPr/>
         </p:nvSpPr>
@@ -12595,14 +13443,58 @@
       </p:sp>
       <p:sp>
         <p:nvSpPr>
-          <p:cNvPr id="10" name="TextBox 9"/>
+          <p:cNvPr id="11" name="Rounded Rectangle 10"/>
+          <p:cNvSpPr/>
+          <p:nvPr/>
+        </p:nvSpPr>
+        <p:spPr>
+          <a:xfrm>
+            <a:off x="2990088" y="2194560"/>
+            <a:ext cx="1691640" cy="64008"/>
+          </a:xfrm>
+          <a:prstGeom prst="roundRect">
+            <a:avLst/>
+          </a:prstGeom>
+          <a:solidFill>
+            <a:srgbClr val="E6EDF3"/>
+          </a:solidFill>
+          <a:ln>
+            <a:noFill/>
+          </a:ln>
+          <a:effectLst/>
+        </p:spPr>
+        <p:style>
+          <a:lnRef idx="1">
+            <a:schemeClr val="accent1"/>
+          </a:lnRef>
+          <a:fillRef idx="3">
+            <a:schemeClr val="accent1"/>
+          </a:fillRef>
+          <a:effectRef idx="2">
+            <a:schemeClr val="accent1"/>
+          </a:effectRef>
+          <a:fontRef idx="minor">
+            <a:schemeClr val="lt1"/>
+          </a:fontRef>
+        </p:style>
+        <p:txBody>
+          <a:bodyPr rtlCol="0" anchor="ctr"/>
+          <a:lstStyle/>
+          <a:p>
+            <a:pPr algn="ctr"/>
+          </a:p>
+        </p:txBody>
+      </p:sp>
+      <p:sp>
+        <p:nvSpPr>
+          <p:cNvPr id="12" name="TextBox 11"/>
           <p:cNvSpPr txBox="1"/>
           <p:nvPr/>
         </p:nvSpPr>
         <p:spPr>
           <a:xfrm>
-            <a:off x="2971800" y="2148840"/>
-            <a:ext cx="1728216" cy="1051560"/>
+            <a:off x="2971800" y="2203704"/>
+            <a:ext cx="1728216" cy="996695"/>
           </a:xfrm>
           <a:prstGeom prst="rect">
             <a:avLst/>
@@ -12662,7 +13554,7 @@
       </p:sp>
       <p:sp>
         <p:nvSpPr>
-          <p:cNvPr id="11" name="TextBox 10"/>
+          <p:cNvPr id="13" name="TextBox 12"/>
           <p:cNvSpPr txBox="1"/>
           <p:nvPr/>
         </p:nvSpPr>
@@ -12707,7 +13599,7 @@
       </p:sp>
       <p:sp>
         <p:nvSpPr>
-          <p:cNvPr id="12" name="Rounded Rectangle 11"/>
+          <p:cNvPr id="14" name="Rounded Rectangle 13"/>
           <p:cNvSpPr/>
           <p:nvPr/>
         </p:nvSpPr>
@@ -12753,14 +13645,58 @@
       </p:sp>
       <p:sp>
         <p:nvSpPr>
-          <p:cNvPr id="13" name="TextBox 12"/>
+          <p:cNvPr id="15" name="Rounded Rectangle 14"/>
+          <p:cNvSpPr/>
+          <p:nvPr/>
+        </p:nvSpPr>
+        <p:spPr>
+          <a:xfrm>
+            <a:off x="5248656" y="2194560"/>
+            <a:ext cx="1691640" cy="64008"/>
+          </a:xfrm>
+          <a:prstGeom prst="roundRect">
+            <a:avLst/>
+          </a:prstGeom>
+          <a:solidFill>
+            <a:srgbClr val="F5A623"/>
+          </a:solidFill>
+          <a:ln>
+            <a:noFill/>
+          </a:ln>
+          <a:effectLst/>
+        </p:spPr>
+        <p:style>
+          <a:lnRef idx="1">
+            <a:schemeClr val="accent1"/>
+          </a:lnRef>
+          <a:fillRef idx="3">
+            <a:schemeClr val="accent1"/>
+          </a:fillRef>
+          <a:effectRef idx="2">
+            <a:schemeClr val="accent1"/>
+          </a:effectRef>
+          <a:fontRef idx="minor">
+            <a:schemeClr val="lt1"/>
+          </a:fontRef>
+        </p:style>
+        <p:txBody>
+          <a:bodyPr rtlCol="0" anchor="ctr"/>
+          <a:lstStyle/>
+          <a:p>
+            <a:pPr algn="ctr"/>
+          </a:p>
+        </p:txBody>
+      </p:sp>
+      <p:sp>
+        <p:nvSpPr>
+          <p:cNvPr id="16" name="TextBox 15"/>
           <p:cNvSpPr txBox="1"/>
           <p:nvPr/>
         </p:nvSpPr>
         <p:spPr>
           <a:xfrm>
-            <a:off x="5230368" y="2148840"/>
-            <a:ext cx="1728216" cy="1051560"/>
+            <a:off x="5230368" y="2203704"/>
+            <a:ext cx="1728216" cy="996695"/>
           </a:xfrm>
           <a:prstGeom prst="rect">
             <a:avLst/>
@@ -12820,7 +13756,7 @@
       </p:sp>
       <p:sp>
         <p:nvSpPr>
-          <p:cNvPr id="14" name="TextBox 13"/>
+          <p:cNvPr id="17" name="TextBox 16"/>
           <p:cNvSpPr txBox="1"/>
           <p:nvPr/>
         </p:nvSpPr>
@@ -12865,7 +13801,7 @@
       </p:sp>
       <p:sp>
         <p:nvSpPr>
-          <p:cNvPr id="15" name="Rounded Rectangle 14"/>
+          <p:cNvPr id="18" name="Rounded Rectangle 17"/>
           <p:cNvSpPr/>
           <p:nvPr/>
         </p:nvSpPr>
@@ -12911,14 +13847,58 @@
       </p:sp>
       <p:sp>
         <p:nvSpPr>
-          <p:cNvPr id="16" name="TextBox 15"/>
+          <p:cNvPr id="19" name="Rounded Rectangle 18"/>
+          <p:cNvSpPr/>
+          <p:nvPr/>
+        </p:nvSpPr>
+        <p:spPr>
+          <a:xfrm>
+            <a:off x="7507224" y="2194560"/>
+            <a:ext cx="1691640" cy="64008"/>
+          </a:xfrm>
+          <a:prstGeom prst="roundRect">
+            <a:avLst/>
+          </a:prstGeom>
+          <a:solidFill>
+            <a:srgbClr val="F5A623"/>
+          </a:solidFill>
+          <a:ln>
+            <a:noFill/>
+          </a:ln>
+          <a:effectLst/>
+        </p:spPr>
+        <p:style>
+          <a:lnRef idx="1">
+            <a:schemeClr val="accent1"/>
+          </a:lnRef>
+          <a:fillRef idx="3">
+            <a:schemeClr val="accent1"/>
+          </a:fillRef>
+          <a:effectRef idx="2">
+            <a:schemeClr val="accent1"/>
+          </a:effectRef>
+          <a:fontRef idx="minor">
+            <a:schemeClr val="lt1"/>
+          </a:fontRef>
+        </p:style>
+        <p:txBody>
+          <a:bodyPr rtlCol="0" anchor="ctr"/>
+          <a:lstStyle/>
+          <a:p>
+            <a:pPr algn="ctr"/>
+          </a:p>
+        </p:txBody>
+      </p:sp>
+      <p:sp>
+        <p:nvSpPr>
+          <p:cNvPr id="20" name="TextBox 19"/>
           <p:cNvSpPr txBox="1"/>
           <p:nvPr/>
         </p:nvSpPr>
         <p:spPr>
           <a:xfrm>
-            <a:off x="7488936" y="2148840"/>
-            <a:ext cx="1728216" cy="1051560"/>
+            <a:off x="7488936" y="2203704"/>
+            <a:ext cx="1728216" cy="996695"/>
           </a:xfrm>
           <a:prstGeom prst="rect">
             <a:avLst/>
@@ -12978,7 +13958,7 @@
       </p:sp>
       <p:sp>
         <p:nvSpPr>
-          <p:cNvPr id="17" name="TextBox 16"/>
+          <p:cNvPr id="21" name="TextBox 20"/>
           <p:cNvSpPr txBox="1"/>
           <p:nvPr/>
         </p:nvSpPr>
@@ -13023,7 +14003,7 @@
       </p:sp>
       <p:sp>
         <p:nvSpPr>
-          <p:cNvPr id="18" name="Rounded Rectangle 17"/>
+          <p:cNvPr id="22" name="Rounded Rectangle 21"/>
           <p:cNvSpPr/>
           <p:nvPr/>
         </p:nvSpPr>
@@ -13069,14 +14049,58 @@
       </p:sp>
       <p:sp>
         <p:nvSpPr>
-          <p:cNvPr id="19" name="TextBox 18"/>
+          <p:cNvPr id="23" name="Rounded Rectangle 22"/>
+          <p:cNvSpPr/>
+          <p:nvPr/>
+        </p:nvSpPr>
+        <p:spPr>
+          <a:xfrm>
+            <a:off x="9765792" y="2194560"/>
+            <a:ext cx="1691640" cy="64008"/>
+          </a:xfrm>
+          <a:prstGeom prst="roundRect">
+            <a:avLst/>
+          </a:prstGeom>
+          <a:solidFill>
+            <a:srgbClr val="3FD0C8"/>
+          </a:solidFill>
+          <a:ln>
+            <a:noFill/>
+          </a:ln>
+          <a:effectLst/>
+        </p:spPr>
+        <p:style>
+          <a:lnRef idx="1">
+            <a:schemeClr val="accent1"/>
+          </a:lnRef>
+          <a:fillRef idx="3">
+            <a:schemeClr val="accent1"/>
+          </a:fillRef>
+          <a:effectRef idx="2">
+            <a:schemeClr val="accent1"/>
+          </a:effectRef>
+          <a:fontRef idx="minor">
+            <a:schemeClr val="lt1"/>
+          </a:fontRef>
+        </p:style>
+        <p:txBody>
+          <a:bodyPr rtlCol="0" anchor="ctr"/>
+          <a:lstStyle/>
+          <a:p>
+            <a:pPr algn="ctr"/>
+          </a:p>
+        </p:txBody>
+      </p:sp>
+      <p:sp>
+        <p:nvSpPr>
+          <p:cNvPr id="24" name="TextBox 23"/>
           <p:cNvSpPr txBox="1"/>
           <p:nvPr/>
         </p:nvSpPr>
         <p:spPr>
           <a:xfrm>
-            <a:off x="9747504" y="2148840"/>
-            <a:ext cx="1728216" cy="1051560"/>
+            <a:off x="9747504" y="2203704"/>
+            <a:ext cx="1728216" cy="996695"/>
           </a:xfrm>
           <a:prstGeom prst="rect">
             <a:avLst/>
@@ -13136,7 +14160,7 @@
       </p:sp>
       <p:sp>
         <p:nvSpPr>
-          <p:cNvPr id="20" name="Rounded Rectangle 19"/>
+          <p:cNvPr id="25" name="Rounded Rectangle 24"/>
           <p:cNvSpPr/>
           <p:nvPr/>
         </p:nvSpPr>
@@ -13182,7 +14206,7 @@
       </p:sp>
       <p:sp>
         <p:nvSpPr>
-          <p:cNvPr id="21" name="TextBox 20"/>
+          <p:cNvPr id="26" name="TextBox 25"/>
           <p:cNvSpPr txBox="1"/>
           <p:nvPr/>
         </p:nvSpPr>
@@ -13320,7 +14344,7 @@
       </p:sp>
       <p:sp>
         <p:nvSpPr>
-          <p:cNvPr id="22" name="Rounded Rectangle 21"/>
+          <p:cNvPr id="27" name="Rounded Rectangle 26"/>
           <p:cNvSpPr/>
           <p:nvPr/>
         </p:nvSpPr>
@@ -13366,7 +14390,7 @@
       </p:sp>
       <p:sp>
         <p:nvSpPr>
-          <p:cNvPr id="23" name="TextBox 22"/>
+          <p:cNvPr id="28" name="TextBox 27"/>
           <p:cNvSpPr txBox="1"/>
           <p:nvPr/>
         </p:nvSpPr>
@@ -14959,14 +15983,58 @@
       </p:sp>
       <p:sp>
         <p:nvSpPr>
-          <p:cNvPr id="8" name="TextBox 7"/>
+          <p:cNvPr id="8" name="Rounded Rectangle 7"/>
+          <p:cNvSpPr/>
+          <p:nvPr/>
+        </p:nvSpPr>
+        <p:spPr>
+          <a:xfrm>
+            <a:off x="731519" y="3246120"/>
+            <a:ext cx="2256282" cy="64008"/>
+          </a:xfrm>
+          <a:prstGeom prst="roundRect">
+            <a:avLst/>
+          </a:prstGeom>
+          <a:solidFill>
+            <a:srgbClr val="58A6FF"/>
+          </a:solidFill>
+          <a:ln>
+            <a:noFill/>
+          </a:ln>
+          <a:effectLst/>
+        </p:spPr>
+        <p:style>
+          <a:lnRef idx="1">
+            <a:schemeClr val="accent1"/>
+          </a:lnRef>
+          <a:fillRef idx="3">
+            <a:schemeClr val="accent1"/>
+          </a:fillRef>
+          <a:effectRef idx="2">
+            <a:schemeClr val="accent1"/>
+          </a:effectRef>
+          <a:fontRef idx="minor">
+            <a:schemeClr val="lt1"/>
+          </a:fontRef>
+        </p:style>
+        <p:txBody>
+          <a:bodyPr rtlCol="0" anchor="ctr"/>
+          <a:lstStyle/>
+          <a:p>
+            <a:pPr algn="ctr"/>
+          </a:p>
+        </p:txBody>
+      </p:sp>
+      <p:sp>
+        <p:nvSpPr>
+          <p:cNvPr id="9" name="TextBox 8"/>
           <p:cNvSpPr txBox="1"/>
           <p:nvPr/>
         </p:nvSpPr>
         <p:spPr>
           <a:xfrm>
-            <a:off x="713231" y="3200400"/>
-            <a:ext cx="2292858" cy="1005840"/>
+            <a:off x="713231" y="3255264"/>
+            <a:ext cx="2292858" cy="950976"/>
           </a:xfrm>
           <a:prstGeom prst="rect">
             <a:avLst/>
@@ -15026,7 +16094,7 @@
       </p:sp>
       <p:sp>
         <p:nvSpPr>
-          <p:cNvPr id="9" name="TextBox 8"/>
+          <p:cNvPr id="10" name="TextBox 9"/>
           <p:cNvSpPr txBox="1"/>
           <p:nvPr/>
         </p:nvSpPr>
@@ -15071,7 +16139,7 @@
       </p:sp>
       <p:sp>
         <p:nvSpPr>
-          <p:cNvPr id="10" name="Rounded Rectangle 9"/>
+          <p:cNvPr id="11" name="Rounded Rectangle 10"/>
           <p:cNvSpPr/>
           <p:nvPr/>
         </p:nvSpPr>
@@ -15117,14 +16185,58 @@
       </p:sp>
       <p:sp>
         <p:nvSpPr>
-          <p:cNvPr id="11" name="TextBox 10"/>
+          <p:cNvPr id="12" name="Rounded Rectangle 11"/>
+          <p:cNvSpPr/>
+          <p:nvPr/>
+        </p:nvSpPr>
+        <p:spPr>
+          <a:xfrm>
+            <a:off x="3554730" y="3246120"/>
+            <a:ext cx="2256282" cy="64008"/>
+          </a:xfrm>
+          <a:prstGeom prst="roundRect">
+            <a:avLst/>
+          </a:prstGeom>
+          <a:solidFill>
+            <a:srgbClr val="E6EDF3"/>
+          </a:solidFill>
+          <a:ln>
+            <a:noFill/>
+          </a:ln>
+          <a:effectLst/>
+        </p:spPr>
+        <p:style>
+          <a:lnRef idx="1">
+            <a:schemeClr val="accent1"/>
+          </a:lnRef>
+          <a:fillRef idx="3">
+            <a:schemeClr val="accent1"/>
+          </a:fillRef>
+          <a:effectRef idx="2">
+            <a:schemeClr val="accent1"/>
+          </a:effectRef>
+          <a:fontRef idx="minor">
+            <a:schemeClr val="lt1"/>
+          </a:fontRef>
+        </p:style>
+        <p:txBody>
+          <a:bodyPr rtlCol="0" anchor="ctr"/>
+          <a:lstStyle/>
+          <a:p>
+            <a:pPr algn="ctr"/>
+          </a:p>
+        </p:txBody>
+      </p:sp>
+      <p:sp>
+        <p:nvSpPr>
+          <p:cNvPr id="13" name="TextBox 12"/>
           <p:cNvSpPr txBox="1"/>
           <p:nvPr/>
         </p:nvSpPr>
         <p:spPr>
           <a:xfrm>
-            <a:off x="3536442" y="3200400"/>
-            <a:ext cx="2292858" cy="1005840"/>
+            <a:off x="3536442" y="3255264"/>
+            <a:ext cx="2292858" cy="950976"/>
           </a:xfrm>
           <a:prstGeom prst="rect">
             <a:avLst/>
@@ -15184,7 +16296,7 @@
       </p:sp>
       <p:sp>
         <p:nvSpPr>
-          <p:cNvPr id="12" name="TextBox 11"/>
+          <p:cNvPr id="14" name="TextBox 13"/>
           <p:cNvSpPr txBox="1"/>
           <p:nvPr/>
         </p:nvSpPr>
@@ -15229,7 +16341,7 @@
       </p:sp>
       <p:sp>
         <p:nvSpPr>
-          <p:cNvPr id="13" name="Rounded Rectangle 12"/>
+          <p:cNvPr id="15" name="Rounded Rectangle 14"/>
           <p:cNvSpPr/>
           <p:nvPr/>
         </p:nvSpPr>
@@ -15275,14 +16387,58 @@
       </p:sp>
       <p:sp>
         <p:nvSpPr>
-          <p:cNvPr id="14" name="TextBox 13"/>
+          <p:cNvPr id="16" name="Rounded Rectangle 15"/>
+          <p:cNvSpPr/>
+          <p:nvPr/>
+        </p:nvSpPr>
+        <p:spPr>
+          <a:xfrm>
+            <a:off x="6377940" y="3246120"/>
+            <a:ext cx="2256282" cy="64008"/>
+          </a:xfrm>
+          <a:prstGeom prst="roundRect">
+            <a:avLst/>
+          </a:prstGeom>
+          <a:solidFill>
+            <a:srgbClr val="3FB950"/>
+          </a:solidFill>
+          <a:ln>
+            <a:noFill/>
+          </a:ln>
+          <a:effectLst/>
+        </p:spPr>
+        <p:style>
+          <a:lnRef idx="1">
+            <a:schemeClr val="accent1"/>
+          </a:lnRef>
+          <a:fillRef idx="3">
+            <a:schemeClr val="accent1"/>
+          </a:fillRef>
+          <a:effectRef idx="2">
+            <a:schemeClr val="accent1"/>
+          </a:effectRef>
+          <a:fontRef idx="minor">
+            <a:schemeClr val="lt1"/>
+          </a:fontRef>
+        </p:style>
+        <p:txBody>
+          <a:bodyPr rtlCol="0" anchor="ctr"/>
+          <a:lstStyle/>
+          <a:p>
+            <a:pPr algn="ctr"/>
+          </a:p>
+        </p:txBody>
+      </p:sp>
+      <p:sp>
+        <p:nvSpPr>
+          <p:cNvPr id="17" name="TextBox 16"/>
           <p:cNvSpPr txBox="1"/>
           <p:nvPr/>
         </p:nvSpPr>
         <p:spPr>
           <a:xfrm>
-            <a:off x="6359652" y="3200400"/>
-            <a:ext cx="2292858" cy="1005840"/>
+            <a:off x="6359652" y="3255264"/>
+            <a:ext cx="2292858" cy="950976"/>
           </a:xfrm>
           <a:prstGeom prst="rect">
             <a:avLst/>
@@ -15342,7 +16498,7 @@
       </p:sp>
       <p:sp>
         <p:nvSpPr>
-          <p:cNvPr id="15" name="TextBox 14"/>
+          <p:cNvPr id="18" name="TextBox 17"/>
           <p:cNvSpPr txBox="1"/>
           <p:nvPr/>
         </p:nvSpPr>
@@ -15387,7 +16543,7 @@
       </p:sp>
       <p:sp>
         <p:nvSpPr>
-          <p:cNvPr id="16" name="Rounded Rectangle 15"/>
+          <p:cNvPr id="19" name="Rounded Rectangle 18"/>
           <p:cNvSpPr/>
           <p:nvPr/>
         </p:nvSpPr>
@@ -15433,14 +16589,58 @@
       </p:sp>
       <p:sp>
         <p:nvSpPr>
-          <p:cNvPr id="17" name="TextBox 16"/>
+          <p:cNvPr id="20" name="Rounded Rectangle 19"/>
+          <p:cNvSpPr/>
+          <p:nvPr/>
+        </p:nvSpPr>
+        <p:spPr>
+          <a:xfrm>
+            <a:off x="9201150" y="3246120"/>
+            <a:ext cx="2256282" cy="64008"/>
+          </a:xfrm>
+          <a:prstGeom prst="roundRect">
+            <a:avLst/>
+          </a:prstGeom>
+          <a:solidFill>
+            <a:srgbClr val="3FD0C8"/>
+          </a:solidFill>
+          <a:ln>
+            <a:noFill/>
+          </a:ln>
+          <a:effectLst/>
+        </p:spPr>
+        <p:style>
+          <a:lnRef idx="1">
+            <a:schemeClr val="accent1"/>
+          </a:lnRef>
+          <a:fillRef idx="3">
+            <a:schemeClr val="accent1"/>
+          </a:fillRef>
+          <a:effectRef idx="2">
+            <a:schemeClr val="accent1"/>
+          </a:effectRef>
+          <a:fontRef idx="minor">
+            <a:schemeClr val="lt1"/>
+          </a:fontRef>
+        </p:style>
+        <p:txBody>
+          <a:bodyPr rtlCol="0" anchor="ctr"/>
+          <a:lstStyle/>
+          <a:p>
+            <a:pPr algn="ctr"/>
+          </a:p>
+        </p:txBody>
+      </p:sp>
+      <p:sp>
+        <p:nvSpPr>
+          <p:cNvPr id="21" name="TextBox 20"/>
           <p:cNvSpPr txBox="1"/>
           <p:nvPr/>
         </p:nvSpPr>
         <p:spPr>
           <a:xfrm>
-            <a:off x="9182862" y="3200400"/>
-            <a:ext cx="2292858" cy="1005840"/>
+            <a:off x="9182862" y="3255264"/>
+            <a:ext cx="2292858" cy="950976"/>
           </a:xfrm>
           <a:prstGeom prst="rect">
             <a:avLst/>
@@ -15500,7 +16700,7 @@
       </p:sp>
       <p:sp>
         <p:nvSpPr>
-          <p:cNvPr id="18" name="Rounded Rectangle 17"/>
+          <p:cNvPr id="22" name="Rounded Rectangle 21"/>
           <p:cNvSpPr/>
           <p:nvPr/>
         </p:nvSpPr>
@@ -15546,7 +16746,7 @@
       </p:sp>
       <p:sp>
         <p:nvSpPr>
-          <p:cNvPr id="19" name="TextBox 18"/>
+          <p:cNvPr id="23" name="TextBox 22"/>
           <p:cNvSpPr txBox="1"/>
           <p:nvPr/>
         </p:nvSpPr>
@@ -15684,7 +16884,7 @@
       </p:sp>
       <p:sp>
         <p:nvSpPr>
-          <p:cNvPr id="20" name="Rounded Rectangle 19"/>
+          <p:cNvPr id="24" name="Rounded Rectangle 23"/>
           <p:cNvSpPr/>
           <p:nvPr/>
         </p:nvSpPr>
@@ -15730,7 +16930,7 @@
       </p:sp>
       <p:sp>
         <p:nvSpPr>
-          <p:cNvPr id="21" name="TextBox 20"/>
+          <p:cNvPr id="25" name="TextBox 24"/>
           <p:cNvSpPr txBox="1"/>
           <p:nvPr/>
         </p:nvSpPr>
@@ -16111,14 +17311,58 @@
       </p:sp>
       <p:sp>
         <p:nvSpPr>
-          <p:cNvPr id="7" name="TextBox 6"/>
+          <p:cNvPr id="7" name="Rounded Rectangle 6"/>
+          <p:cNvSpPr/>
+          <p:nvPr/>
+        </p:nvSpPr>
+        <p:spPr>
+          <a:xfrm>
+            <a:off x="731519" y="2194560"/>
+            <a:ext cx="1691640" cy="64008"/>
+          </a:xfrm>
+          <a:prstGeom prst="roundRect">
+            <a:avLst/>
+          </a:prstGeom>
+          <a:solidFill>
+            <a:srgbClr val="58A6FF"/>
+          </a:solidFill>
+          <a:ln>
+            <a:noFill/>
+          </a:ln>
+          <a:effectLst/>
+        </p:spPr>
+        <p:style>
+          <a:lnRef idx="1">
+            <a:schemeClr val="accent1"/>
+          </a:lnRef>
+          <a:fillRef idx="3">
+            <a:schemeClr val="accent1"/>
+          </a:fillRef>
+          <a:effectRef idx="2">
+            <a:schemeClr val="accent1"/>
+          </a:effectRef>
+          <a:fontRef idx="minor">
+            <a:schemeClr val="lt1"/>
+          </a:fontRef>
+        </p:style>
+        <p:txBody>
+          <a:bodyPr rtlCol="0" anchor="ctr"/>
+          <a:lstStyle/>
+          <a:p>
+            <a:pPr algn="ctr"/>
+          </a:p>
+        </p:txBody>
+      </p:sp>
+      <p:sp>
+        <p:nvSpPr>
+          <p:cNvPr id="8" name="TextBox 7"/>
           <p:cNvSpPr txBox="1"/>
           <p:nvPr/>
         </p:nvSpPr>
         <p:spPr>
           <a:xfrm>
-            <a:off x="713231" y="2148840"/>
-            <a:ext cx="1728216" cy="1051560"/>
+            <a:off x="713231" y="2203704"/>
+            <a:ext cx="1728216" cy="996695"/>
           </a:xfrm>
           <a:prstGeom prst="rect">
             <a:avLst/>
@@ -16156,7 +17400,7 @@
       </p:sp>
       <p:sp>
         <p:nvSpPr>
-          <p:cNvPr id="8" name="TextBox 7"/>
+          <p:cNvPr id="9" name="TextBox 8"/>
           <p:cNvSpPr txBox="1"/>
           <p:nvPr/>
         </p:nvSpPr>
@@ -16201,7 +17445,7 @@
       </p:sp>
       <p:sp>
         <p:nvSpPr>
-          <p:cNvPr id="9" name="Rounded Rectangle 8"/>
+          <p:cNvPr id="10" name="Rounded Rectangle 9"/>
           <p:cNvSpPr/>
           <p:nvPr/>
         </p:nvSpPr>
@@ -16247,14 +17491,58 @@
       </p:sp>
       <p:sp>
         <p:nvSpPr>
-          <p:cNvPr id="10" name="TextBox 9"/>
+          <p:cNvPr id="11" name="Rounded Rectangle 10"/>
+          <p:cNvSpPr/>
+          <p:nvPr/>
+        </p:nvSpPr>
+        <p:spPr>
+          <a:xfrm>
+            <a:off x="2990088" y="2194560"/>
+            <a:ext cx="1691640" cy="64008"/>
+          </a:xfrm>
+          <a:prstGeom prst="roundRect">
+            <a:avLst/>
+          </a:prstGeom>
+          <a:solidFill>
+            <a:srgbClr val="3FB950"/>
+          </a:solidFill>
+          <a:ln>
+            <a:noFill/>
+          </a:ln>
+          <a:effectLst/>
+        </p:spPr>
+        <p:style>
+          <a:lnRef idx="1">
+            <a:schemeClr val="accent1"/>
+          </a:lnRef>
+          <a:fillRef idx="3">
+            <a:schemeClr val="accent1"/>
+          </a:fillRef>
+          <a:effectRef idx="2">
+            <a:schemeClr val="accent1"/>
+          </a:effectRef>
+          <a:fontRef idx="minor">
+            <a:schemeClr val="lt1"/>
+          </a:fontRef>
+        </p:style>
+        <p:txBody>
+          <a:bodyPr rtlCol="0" anchor="ctr"/>
+          <a:lstStyle/>
+          <a:p>
+            <a:pPr algn="ctr"/>
+          </a:p>
+        </p:txBody>
+      </p:sp>
+      <p:sp>
+        <p:nvSpPr>
+          <p:cNvPr id="12" name="TextBox 11"/>
           <p:cNvSpPr txBox="1"/>
           <p:nvPr/>
         </p:nvSpPr>
         <p:spPr>
           <a:xfrm>
-            <a:off x="2971800" y="2148840"/>
-            <a:ext cx="1728216" cy="1051560"/>
+            <a:off x="2971800" y="2203704"/>
+            <a:ext cx="1728216" cy="996695"/>
           </a:xfrm>
           <a:prstGeom prst="rect">
             <a:avLst/>
@@ -16314,7 +17602,7 @@
       </p:sp>
       <p:sp>
         <p:nvSpPr>
-          <p:cNvPr id="11" name="TextBox 10"/>
+          <p:cNvPr id="13" name="TextBox 12"/>
           <p:cNvSpPr txBox="1"/>
           <p:nvPr/>
         </p:nvSpPr>
@@ -16359,7 +17647,7 @@
       </p:sp>
       <p:sp>
         <p:nvSpPr>
-          <p:cNvPr id="12" name="Rounded Rectangle 11"/>
+          <p:cNvPr id="14" name="Rounded Rectangle 13"/>
           <p:cNvSpPr/>
           <p:nvPr/>
         </p:nvSpPr>
@@ -16405,14 +17693,58 @@
       </p:sp>
       <p:sp>
         <p:nvSpPr>
-          <p:cNvPr id="13" name="TextBox 12"/>
+          <p:cNvPr id="15" name="Rounded Rectangle 14"/>
+          <p:cNvSpPr/>
+          <p:nvPr/>
+        </p:nvSpPr>
+        <p:spPr>
+          <a:xfrm>
+            <a:off x="5248656" y="2194560"/>
+            <a:ext cx="1691640" cy="64008"/>
+          </a:xfrm>
+          <a:prstGeom prst="roundRect">
+            <a:avLst/>
+          </a:prstGeom>
+          <a:solidFill>
+            <a:srgbClr val="3FB950"/>
+          </a:solidFill>
+          <a:ln>
+            <a:noFill/>
+          </a:ln>
+          <a:effectLst/>
+        </p:spPr>
+        <p:style>
+          <a:lnRef idx="1">
+            <a:schemeClr val="accent1"/>
+          </a:lnRef>
+          <a:fillRef idx="3">
+            <a:schemeClr val="accent1"/>
+          </a:fillRef>
+          <a:effectRef idx="2">
+            <a:schemeClr val="accent1"/>
+          </a:effectRef>
+          <a:fontRef idx="minor">
+            <a:schemeClr val="lt1"/>
+          </a:fontRef>
+        </p:style>
+        <p:txBody>
+          <a:bodyPr rtlCol="0" anchor="ctr"/>
+          <a:lstStyle/>
+          <a:p>
+            <a:pPr algn="ctr"/>
+          </a:p>
+        </p:txBody>
+      </p:sp>
+      <p:sp>
+        <p:nvSpPr>
+          <p:cNvPr id="16" name="TextBox 15"/>
           <p:cNvSpPr txBox="1"/>
           <p:nvPr/>
         </p:nvSpPr>
         <p:spPr>
           <a:xfrm>
-            <a:off x="5230368" y="2148840"/>
-            <a:ext cx="1728216" cy="1051560"/>
+            <a:off x="5230368" y="2203704"/>
+            <a:ext cx="1728216" cy="996695"/>
           </a:xfrm>
           <a:prstGeom prst="rect">
             <a:avLst/>
@@ -16472,7 +17804,7 @@
       </p:sp>
       <p:sp>
         <p:nvSpPr>
-          <p:cNvPr id="14" name="TextBox 13"/>
+          <p:cNvPr id="17" name="TextBox 16"/>
           <p:cNvSpPr txBox="1"/>
           <p:nvPr/>
         </p:nvSpPr>
@@ -16517,7 +17849,7 @@
       </p:sp>
       <p:sp>
         <p:nvSpPr>
-          <p:cNvPr id="15" name="Rounded Rectangle 14"/>
+          <p:cNvPr id="18" name="Rounded Rectangle 17"/>
           <p:cNvSpPr/>
           <p:nvPr/>
         </p:nvSpPr>
@@ -16563,14 +17895,58 @@
       </p:sp>
       <p:sp>
         <p:nvSpPr>
-          <p:cNvPr id="16" name="TextBox 15"/>
+          <p:cNvPr id="19" name="Rounded Rectangle 18"/>
+          <p:cNvSpPr/>
+          <p:nvPr/>
+        </p:nvSpPr>
+        <p:spPr>
+          <a:xfrm>
+            <a:off x="7507224" y="2194560"/>
+            <a:ext cx="1691640" cy="64008"/>
+          </a:xfrm>
+          <a:prstGeom prst="roundRect">
+            <a:avLst/>
+          </a:prstGeom>
+          <a:solidFill>
+            <a:srgbClr val="3FB950"/>
+          </a:solidFill>
+          <a:ln>
+            <a:noFill/>
+          </a:ln>
+          <a:effectLst/>
+        </p:spPr>
+        <p:style>
+          <a:lnRef idx="1">
+            <a:schemeClr val="accent1"/>
+          </a:lnRef>
+          <a:fillRef idx="3">
+            <a:schemeClr val="accent1"/>
+          </a:fillRef>
+          <a:effectRef idx="2">
+            <a:schemeClr val="accent1"/>
+          </a:effectRef>
+          <a:fontRef idx="minor">
+            <a:schemeClr val="lt1"/>
+          </a:fontRef>
+        </p:style>
+        <p:txBody>
+          <a:bodyPr rtlCol="0" anchor="ctr"/>
+          <a:lstStyle/>
+          <a:p>
+            <a:pPr algn="ctr"/>
+          </a:p>
+        </p:txBody>
+      </p:sp>
+      <p:sp>
+        <p:nvSpPr>
+          <p:cNvPr id="20" name="TextBox 19"/>
           <p:cNvSpPr txBox="1"/>
           <p:nvPr/>
         </p:nvSpPr>
         <p:spPr>
           <a:xfrm>
-            <a:off x="7488936" y="2148840"/>
-            <a:ext cx="1728216" cy="1051560"/>
+            <a:off x="7488936" y="2203704"/>
+            <a:ext cx="1728216" cy="996695"/>
           </a:xfrm>
           <a:prstGeom prst="rect">
             <a:avLst/>
@@ -16630,7 +18006,7 @@
       </p:sp>
       <p:sp>
         <p:nvSpPr>
-          <p:cNvPr id="17" name="TextBox 16"/>
+          <p:cNvPr id="21" name="TextBox 20"/>
           <p:cNvSpPr txBox="1"/>
           <p:nvPr/>
         </p:nvSpPr>
@@ -16675,7 +18051,7 @@
       </p:sp>
       <p:sp>
         <p:nvSpPr>
-          <p:cNvPr id="18" name="Rounded Rectangle 17"/>
+          <p:cNvPr id="22" name="Rounded Rectangle 21"/>
           <p:cNvSpPr/>
           <p:nvPr/>
         </p:nvSpPr>
@@ -16721,14 +18097,58 @@
       </p:sp>
       <p:sp>
         <p:nvSpPr>
-          <p:cNvPr id="19" name="TextBox 18"/>
+          <p:cNvPr id="23" name="Rounded Rectangle 22"/>
+          <p:cNvSpPr/>
+          <p:nvPr/>
+        </p:nvSpPr>
+        <p:spPr>
+          <a:xfrm>
+            <a:off x="9765792" y="2194560"/>
+            <a:ext cx="1691640" cy="64008"/>
+          </a:xfrm>
+          <a:prstGeom prst="roundRect">
+            <a:avLst/>
+          </a:prstGeom>
+          <a:solidFill>
+            <a:srgbClr val="3FD0C8"/>
+          </a:solidFill>
+          <a:ln>
+            <a:noFill/>
+          </a:ln>
+          <a:effectLst/>
+        </p:spPr>
+        <p:style>
+          <a:lnRef idx="1">
+            <a:schemeClr val="accent1"/>
+          </a:lnRef>
+          <a:fillRef idx="3">
+            <a:schemeClr val="accent1"/>
+          </a:fillRef>
+          <a:effectRef idx="2">
+            <a:schemeClr val="accent1"/>
+          </a:effectRef>
+          <a:fontRef idx="minor">
+            <a:schemeClr val="lt1"/>
+          </a:fontRef>
+        </p:style>
+        <p:txBody>
+          <a:bodyPr rtlCol="0" anchor="ctr"/>
+          <a:lstStyle/>
+          <a:p>
+            <a:pPr algn="ctr"/>
+          </a:p>
+        </p:txBody>
+      </p:sp>
+      <p:sp>
+        <p:nvSpPr>
+          <p:cNvPr id="24" name="TextBox 23"/>
           <p:cNvSpPr txBox="1"/>
           <p:nvPr/>
         </p:nvSpPr>
         <p:spPr>
           <a:xfrm>
-            <a:off x="9747504" y="2148840"/>
-            <a:ext cx="1728216" cy="1051560"/>
+            <a:off x="9747504" y="2203704"/>
+            <a:ext cx="1728216" cy="996695"/>
           </a:xfrm>
           <a:prstGeom prst="rect">
             <a:avLst/>
@@ -16788,14 +18208,378 @@
       </p:sp>
       <p:sp>
         <p:nvSpPr>
-          <p:cNvPr id="20" name="Rounded Rectangle 19"/>
+          <p:cNvPr id="25" name="Rounded Rectangle 24"/>
           <p:cNvSpPr/>
           <p:nvPr/>
         </p:nvSpPr>
         <p:spPr>
           <a:xfrm>
-            <a:off x="640080" y="3794760"/>
-            <a:ext cx="10927080" cy="2331720"/>
+            <a:off x="2319375" y="3364992"/>
+            <a:ext cx="1563624" cy="384048"/>
+          </a:xfrm>
+          <a:prstGeom prst="roundRect">
+            <a:avLst/>
+          </a:prstGeom>
+          <a:solidFill>
+            <a:srgbClr val="161B22"/>
+          </a:solidFill>
+          <a:ln w="12700">
+            <a:solidFill>
+              <a:srgbClr val="30363D"/>
+            </a:solidFill>
+          </a:ln>
+          <a:effectLst/>
+        </p:spPr>
+        <p:style>
+          <a:lnRef idx="1">
+            <a:schemeClr val="accent1"/>
+          </a:lnRef>
+          <a:fillRef idx="3">
+            <a:schemeClr val="accent1"/>
+          </a:fillRef>
+          <a:effectRef idx="2">
+            <a:schemeClr val="accent1"/>
+          </a:effectRef>
+          <a:fontRef idx="minor">
+            <a:schemeClr val="lt1"/>
+          </a:fontRef>
+        </p:style>
+        <p:txBody>
+          <a:bodyPr rtlCol="0" anchor="ctr"/>
+          <a:lstStyle/>
+          <a:p>
+            <a:pPr algn="ctr"/>
+          </a:p>
+        </p:txBody>
+      </p:sp>
+      <p:sp>
+        <p:nvSpPr>
+          <p:cNvPr id="26" name="TextBox 25"/>
+          <p:cNvSpPr txBox="1"/>
+          <p:nvPr/>
+        </p:nvSpPr>
+        <p:spPr>
+          <a:xfrm>
+            <a:off x="2319375" y="3364992"/>
+            <a:ext cx="1563624" cy="384048"/>
+          </a:xfrm>
+          <a:prstGeom prst="rect">
+            <a:avLst/>
+          </a:prstGeom>
+          <a:noFill/>
+        </p:spPr>
+        <p:txBody>
+          <a:bodyPr wrap="square" anchor="ctr" lIns="0" rIns="0" tIns="0" bIns="0">
+            <a:spAutoFit/>
+          </a:bodyPr>
+          <a:lstStyle/>
+          <a:p>
+            <a:pPr algn="ctr">
+              <a:lnSpc>
+                <a:spcPct val="100000"/>
+              </a:lnSpc>
+              <a:spcBef>
+                <a:spcPts val="0"/>
+              </a:spcBef>
+              <a:spcAft>
+                <a:spcPts val="200"/>
+              </a:spcAft>
+            </a:pPr>
+            <a:r>
+              <a:rPr sz="1100" b="1">
+                <a:solidFill>
+                  <a:srgbClr val="3FB950"/>
+                </a:solidFill>
+                <a:latin typeface="Consolas"/>
+              </a:rPr>
+              <a:t>0 tail call</a:t>
+            </a:r>
+          </a:p>
+        </p:txBody>
+      </p:sp>
+      <p:sp>
+        <p:nvSpPr>
+          <p:cNvPr id="27" name="Rounded Rectangle 26"/>
+          <p:cNvSpPr/>
+          <p:nvPr/>
+        </p:nvSpPr>
+        <p:spPr>
+          <a:xfrm>
+            <a:off x="4047591" y="3364992"/>
+            <a:ext cx="1764792" cy="384048"/>
+          </a:xfrm>
+          <a:prstGeom prst="roundRect">
+            <a:avLst/>
+          </a:prstGeom>
+          <a:solidFill>
+            <a:srgbClr val="161B22"/>
+          </a:solidFill>
+          <a:ln w="12700">
+            <a:solidFill>
+              <a:srgbClr val="30363D"/>
+            </a:solidFill>
+          </a:ln>
+          <a:effectLst/>
+        </p:spPr>
+        <p:style>
+          <a:lnRef idx="1">
+            <a:schemeClr val="accent1"/>
+          </a:lnRef>
+          <a:fillRef idx="3">
+            <a:schemeClr val="accent1"/>
+          </a:fillRef>
+          <a:effectRef idx="2">
+            <a:schemeClr val="accent1"/>
+          </a:effectRef>
+          <a:fontRef idx="minor">
+            <a:schemeClr val="lt1"/>
+          </a:fontRef>
+        </p:style>
+        <p:txBody>
+          <a:bodyPr rtlCol="0" anchor="ctr"/>
+          <a:lstStyle/>
+          <a:p>
+            <a:pPr algn="ctr"/>
+          </a:p>
+        </p:txBody>
+      </p:sp>
+      <p:sp>
+        <p:nvSpPr>
+          <p:cNvPr id="28" name="TextBox 27"/>
+          <p:cNvSpPr txBox="1"/>
+          <p:nvPr/>
+        </p:nvSpPr>
+        <p:spPr>
+          <a:xfrm>
+            <a:off x="4047591" y="3364992"/>
+            <a:ext cx="1764792" cy="384048"/>
+          </a:xfrm>
+          <a:prstGeom prst="rect">
+            <a:avLst/>
+          </a:prstGeom>
+          <a:noFill/>
+        </p:spPr>
+        <p:txBody>
+          <a:bodyPr wrap="square" anchor="ctr" lIns="0" rIns="0" tIns="0" bIns="0">
+            <a:spAutoFit/>
+          </a:bodyPr>
+          <a:lstStyle/>
+          <a:p>
+            <a:pPr algn="ctr">
+              <a:lnSpc>
+                <a:spcPct val="100000"/>
+              </a:lnSpc>
+              <a:spcBef>
+                <a:spcPts val="0"/>
+              </a:spcBef>
+              <a:spcAft>
+                <a:spcPts val="200"/>
+              </a:spcAft>
+            </a:pPr>
+            <a:r>
+              <a:rPr sz="1100" b="1">
+                <a:solidFill>
+                  <a:srgbClr val="3FB950"/>
+                </a:solidFill>
+                <a:latin typeface="Consolas"/>
+              </a:rPr>
+              <a:t>0 lookup pesi</a:t>
+            </a:r>
+          </a:p>
+        </p:txBody>
+      </p:sp>
+      <p:sp>
+        <p:nvSpPr>
+          <p:cNvPr id="29" name="Rounded Rectangle 28"/>
+          <p:cNvSpPr/>
+          <p:nvPr/>
+        </p:nvSpPr>
+        <p:spPr>
+          <a:xfrm>
+            <a:off x="5976975" y="3364992"/>
+            <a:ext cx="1563624" cy="384048"/>
+          </a:xfrm>
+          <a:prstGeom prst="roundRect">
+            <a:avLst/>
+          </a:prstGeom>
+          <a:solidFill>
+            <a:srgbClr val="161B22"/>
+          </a:solidFill>
+          <a:ln w="12700">
+            <a:solidFill>
+              <a:srgbClr val="30363D"/>
+            </a:solidFill>
+          </a:ln>
+          <a:effectLst/>
+        </p:spPr>
+        <p:style>
+          <a:lnRef idx="1">
+            <a:schemeClr val="accent1"/>
+          </a:lnRef>
+          <a:fillRef idx="3">
+            <a:schemeClr val="accent1"/>
+          </a:fillRef>
+          <a:effectRef idx="2">
+            <a:schemeClr val="accent1"/>
+          </a:effectRef>
+          <a:fontRef idx="minor">
+            <a:schemeClr val="lt1"/>
+          </a:fontRef>
+        </p:style>
+        <p:txBody>
+          <a:bodyPr rtlCol="0" anchor="ctr"/>
+          <a:lstStyle/>
+          <a:p>
+            <a:pPr algn="ctr"/>
+          </a:p>
+        </p:txBody>
+      </p:sp>
+      <p:sp>
+        <p:nvSpPr>
+          <p:cNvPr id="30" name="TextBox 29"/>
+          <p:cNvSpPr txBox="1"/>
+          <p:nvPr/>
+        </p:nvSpPr>
+        <p:spPr>
+          <a:xfrm>
+            <a:off x="5976975" y="3364992"/>
+            <a:ext cx="1563624" cy="384048"/>
+          </a:xfrm>
+          <a:prstGeom prst="rect">
+            <a:avLst/>
+          </a:prstGeom>
+          <a:noFill/>
+        </p:spPr>
+        <p:txBody>
+          <a:bodyPr wrap="square" anchor="ctr" lIns="0" rIns="0" tIns="0" bIns="0">
+            <a:spAutoFit/>
+          </a:bodyPr>
+          <a:lstStyle/>
+          <a:p>
+            <a:pPr algn="ctr">
+              <a:lnSpc>
+                <a:spcPct val="100000"/>
+              </a:lnSpc>
+              <a:spcBef>
+                <a:spcPts val="0"/>
+              </a:spcBef>
+              <a:spcAft>
+                <a:spcPts val="200"/>
+              </a:spcAft>
+            </a:pPr>
+            <a:r>
+              <a:rPr sz="1100" b="1">
+                <a:solidFill>
+                  <a:srgbClr val="3FB950"/>
+                </a:solidFill>
+                <a:latin typeface="Consolas"/>
+              </a:rPr>
+              <a:t>264 B mappe</a:t>
+            </a:r>
+          </a:p>
+        </p:txBody>
+      </p:sp>
+      <p:sp>
+        <p:nvSpPr>
+          <p:cNvPr id="31" name="Rounded Rectangle 30"/>
+          <p:cNvSpPr/>
+          <p:nvPr/>
+        </p:nvSpPr>
+        <p:spPr>
+          <a:xfrm>
+            <a:off x="7705191" y="3364992"/>
+            <a:ext cx="2167128" cy="384048"/>
+          </a:xfrm>
+          <a:prstGeom prst="roundRect">
+            <a:avLst/>
+          </a:prstGeom>
+          <a:solidFill>
+            <a:srgbClr val="161B22"/>
+          </a:solidFill>
+          <a:ln w="12700">
+            <a:solidFill>
+              <a:srgbClr val="30363D"/>
+            </a:solidFill>
+          </a:ln>
+          <a:effectLst/>
+        </p:spPr>
+        <p:style>
+          <a:lnRef idx="1">
+            <a:schemeClr val="accent1"/>
+          </a:lnRef>
+          <a:fillRef idx="3">
+            <a:schemeClr val="accent1"/>
+          </a:fillRef>
+          <a:effectRef idx="2">
+            <a:schemeClr val="accent1"/>
+          </a:effectRef>
+          <a:fontRef idx="minor">
+            <a:schemeClr val="lt1"/>
+          </a:fontRef>
+        </p:style>
+        <p:txBody>
+          <a:bodyPr rtlCol="0" anchor="ctr"/>
+          <a:lstStyle/>
+          <a:p>
+            <a:pPr algn="ctr"/>
+          </a:p>
+        </p:txBody>
+      </p:sp>
+      <p:sp>
+        <p:nvSpPr>
+          <p:cNvPr id="32" name="TextBox 31"/>
+          <p:cNvSpPr txBox="1"/>
+          <p:nvPr/>
+        </p:nvSpPr>
+        <p:spPr>
+          <a:xfrm>
+            <a:off x="7705191" y="3364992"/>
+            <a:ext cx="2167128" cy="384048"/>
+          </a:xfrm>
+          <a:prstGeom prst="rect">
+            <a:avLst/>
+          </a:prstGeom>
+          <a:noFill/>
+        </p:spPr>
+        <p:txBody>
+          <a:bodyPr wrap="square" anchor="ctr" lIns="0" rIns="0" tIns="0" bIns="0">
+            <a:spAutoFit/>
+          </a:bodyPr>
+          <a:lstStyle/>
+          <a:p>
+            <a:pPr algn="ctr">
+              <a:lnSpc>
+                <a:spcPct val="100000"/>
+              </a:lnSpc>
+              <a:spcBef>
+                <a:spcPts val="0"/>
+              </a:spcBef>
+              <a:spcAft>
+                <a:spcPts val="200"/>
+              </a:spcAft>
+            </a:pPr>
+            <a:r>
+              <a:rPr sz="1100" b="1">
+                <a:solidFill>
+                  <a:srgbClr val="3FB950"/>
+                </a:solidFill>
+                <a:latin typeface="Consolas"/>
+              </a:rPr>
+              <a:t>72 ns · 13.9 Mpps</a:t>
+            </a:r>
+          </a:p>
+        </p:txBody>
+      </p:sp>
+      <p:sp>
+        <p:nvSpPr>
+          <p:cNvPr id="33" name="Rounded Rectangle 32"/>
+          <p:cNvSpPr/>
+          <p:nvPr/>
+        </p:nvSpPr>
+        <p:spPr>
+          <a:xfrm>
+            <a:off x="640080" y="3840480"/>
+            <a:ext cx="10927080" cy="2286000"/>
           </a:xfrm>
           <a:prstGeom prst="roundRect">
             <a:avLst/>
@@ -16834,14 +18618,14 @@
       </p:sp>
       <p:sp>
         <p:nvSpPr>
-          <p:cNvPr id="21" name="TextBox 20"/>
+          <p:cNvPr id="34" name="TextBox 33"/>
           <p:cNvSpPr txBox="1"/>
           <p:nvPr/>
         </p:nvSpPr>
         <p:spPr>
           <a:xfrm>
-            <a:off x="896112" y="3995928"/>
-            <a:ext cx="10469880" cy="1965960"/>
+            <a:off x="896112" y="4041648"/>
+            <a:ext cx="10469880" cy="1920240"/>
           </a:xfrm>
           <a:prstGeom prst="rect">
             <a:avLst/>
@@ -18070,14 +19854,58 @@
       </p:sp>
       <p:sp>
         <p:nvSpPr>
-          <p:cNvPr id="7" name="TextBox 6"/>
+          <p:cNvPr id="7" name="Rounded Rectangle 6"/>
+          <p:cNvSpPr/>
+          <p:nvPr/>
+        </p:nvSpPr>
+        <p:spPr>
+          <a:xfrm>
+            <a:off x="731519" y="2194560"/>
+            <a:ext cx="1691640" cy="64008"/>
+          </a:xfrm>
+          <a:prstGeom prst="roundRect">
+            <a:avLst/>
+          </a:prstGeom>
+          <a:solidFill>
+            <a:srgbClr val="58A6FF"/>
+          </a:solidFill>
+          <a:ln>
+            <a:noFill/>
+          </a:ln>
+          <a:effectLst/>
+        </p:spPr>
+        <p:style>
+          <a:lnRef idx="1">
+            <a:schemeClr val="accent1"/>
+          </a:lnRef>
+          <a:fillRef idx="3">
+            <a:schemeClr val="accent1"/>
+          </a:fillRef>
+          <a:effectRef idx="2">
+            <a:schemeClr val="accent1"/>
+          </a:effectRef>
+          <a:fontRef idx="minor">
+            <a:schemeClr val="lt1"/>
+          </a:fontRef>
+        </p:style>
+        <p:txBody>
+          <a:bodyPr rtlCol="0" anchor="ctr"/>
+          <a:lstStyle/>
+          <a:p>
+            <a:pPr algn="ctr"/>
+          </a:p>
+        </p:txBody>
+      </p:sp>
+      <p:sp>
+        <p:nvSpPr>
+          <p:cNvPr id="8" name="TextBox 7"/>
           <p:cNvSpPr txBox="1"/>
           <p:nvPr/>
         </p:nvSpPr>
         <p:spPr>
           <a:xfrm>
-            <a:off x="713231" y="2148840"/>
-            <a:ext cx="1728216" cy="1051560"/>
+            <a:off x="713231" y="2203704"/>
+            <a:ext cx="1728216" cy="996695"/>
           </a:xfrm>
           <a:prstGeom prst="rect">
             <a:avLst/>
@@ -18115,7 +19943,7 @@
       </p:sp>
       <p:sp>
         <p:nvSpPr>
-          <p:cNvPr id="8" name="TextBox 7"/>
+          <p:cNvPr id="9" name="TextBox 8"/>
           <p:cNvSpPr txBox="1"/>
           <p:nvPr/>
         </p:nvSpPr>
@@ -18160,7 +19988,7 @@
       </p:sp>
       <p:sp>
         <p:nvSpPr>
-          <p:cNvPr id="9" name="Rounded Rectangle 8"/>
+          <p:cNvPr id="10" name="Rounded Rectangle 9"/>
           <p:cNvSpPr/>
           <p:nvPr/>
         </p:nvSpPr>
@@ -18206,14 +20034,58 @@
       </p:sp>
       <p:sp>
         <p:nvSpPr>
-          <p:cNvPr id="10" name="TextBox 9"/>
+          <p:cNvPr id="11" name="Rounded Rectangle 10"/>
+          <p:cNvSpPr/>
+          <p:nvPr/>
+        </p:nvSpPr>
+        <p:spPr>
+          <a:xfrm>
+            <a:off x="2990088" y="2194560"/>
+            <a:ext cx="1691640" cy="64008"/>
+          </a:xfrm>
+          <a:prstGeom prst="roundRect">
+            <a:avLst/>
+          </a:prstGeom>
+          <a:solidFill>
+            <a:srgbClr val="E6EDF3"/>
+          </a:solidFill>
+          <a:ln>
+            <a:noFill/>
+          </a:ln>
+          <a:effectLst/>
+        </p:spPr>
+        <p:style>
+          <a:lnRef idx="1">
+            <a:schemeClr val="accent1"/>
+          </a:lnRef>
+          <a:fillRef idx="3">
+            <a:schemeClr val="accent1"/>
+          </a:fillRef>
+          <a:effectRef idx="2">
+            <a:schemeClr val="accent1"/>
+          </a:effectRef>
+          <a:fontRef idx="minor">
+            <a:schemeClr val="lt1"/>
+          </a:fontRef>
+        </p:style>
+        <p:txBody>
+          <a:bodyPr rtlCol="0" anchor="ctr"/>
+          <a:lstStyle/>
+          <a:p>
+            <a:pPr algn="ctr"/>
+          </a:p>
+        </p:txBody>
+      </p:sp>
+      <p:sp>
+        <p:nvSpPr>
+          <p:cNvPr id="12" name="TextBox 11"/>
           <p:cNvSpPr txBox="1"/>
           <p:nvPr/>
         </p:nvSpPr>
         <p:spPr>
           <a:xfrm>
-            <a:off x="2971800" y="2148840"/>
-            <a:ext cx="1728216" cy="1051560"/>
+            <a:off x="2971800" y="2203704"/>
+            <a:ext cx="1728216" cy="996695"/>
           </a:xfrm>
           <a:prstGeom prst="rect">
             <a:avLst/>
@@ -18273,7 +20145,7 @@
       </p:sp>
       <p:sp>
         <p:nvSpPr>
-          <p:cNvPr id="11" name="TextBox 10"/>
+          <p:cNvPr id="13" name="TextBox 12"/>
           <p:cNvSpPr txBox="1"/>
           <p:nvPr/>
         </p:nvSpPr>
@@ -18318,7 +20190,7 @@
       </p:sp>
       <p:sp>
         <p:nvSpPr>
-          <p:cNvPr id="12" name="Rounded Rectangle 11"/>
+          <p:cNvPr id="14" name="Rounded Rectangle 13"/>
           <p:cNvSpPr/>
           <p:nvPr/>
         </p:nvSpPr>
@@ -18364,14 +20236,58 @@
       </p:sp>
       <p:sp>
         <p:nvSpPr>
-          <p:cNvPr id="13" name="TextBox 12"/>
+          <p:cNvPr id="15" name="Rounded Rectangle 14"/>
+          <p:cNvSpPr/>
+          <p:nvPr/>
+        </p:nvSpPr>
+        <p:spPr>
+          <a:xfrm>
+            <a:off x="5248656" y="2194560"/>
+            <a:ext cx="1691640" cy="64008"/>
+          </a:xfrm>
+          <a:prstGeom prst="roundRect">
+            <a:avLst/>
+          </a:prstGeom>
+          <a:solidFill>
+            <a:srgbClr val="F5A623"/>
+          </a:solidFill>
+          <a:ln>
+            <a:noFill/>
+          </a:ln>
+          <a:effectLst/>
+        </p:spPr>
+        <p:style>
+          <a:lnRef idx="1">
+            <a:schemeClr val="accent1"/>
+          </a:lnRef>
+          <a:fillRef idx="3">
+            <a:schemeClr val="accent1"/>
+          </a:fillRef>
+          <a:effectRef idx="2">
+            <a:schemeClr val="accent1"/>
+          </a:effectRef>
+          <a:fontRef idx="minor">
+            <a:schemeClr val="lt1"/>
+          </a:fontRef>
+        </p:style>
+        <p:txBody>
+          <a:bodyPr rtlCol="0" anchor="ctr"/>
+          <a:lstStyle/>
+          <a:p>
+            <a:pPr algn="ctr"/>
+          </a:p>
+        </p:txBody>
+      </p:sp>
+      <p:sp>
+        <p:nvSpPr>
+          <p:cNvPr id="16" name="TextBox 15"/>
           <p:cNvSpPr txBox="1"/>
           <p:nvPr/>
         </p:nvSpPr>
         <p:spPr>
           <a:xfrm>
-            <a:off x="5230368" y="2148840"/>
-            <a:ext cx="1728216" cy="1051560"/>
+            <a:off x="5230368" y="2203704"/>
+            <a:ext cx="1728216" cy="996695"/>
           </a:xfrm>
           <a:prstGeom prst="rect">
             <a:avLst/>
@@ -18431,7 +20347,7 @@
       </p:sp>
       <p:sp>
         <p:nvSpPr>
-          <p:cNvPr id="14" name="TextBox 13"/>
+          <p:cNvPr id="17" name="TextBox 16"/>
           <p:cNvSpPr txBox="1"/>
           <p:nvPr/>
         </p:nvSpPr>
@@ -18476,7 +20392,7 @@
       </p:sp>
       <p:sp>
         <p:nvSpPr>
-          <p:cNvPr id="15" name="Rounded Rectangle 14"/>
+          <p:cNvPr id="18" name="Rounded Rectangle 17"/>
           <p:cNvSpPr/>
           <p:nvPr/>
         </p:nvSpPr>
@@ -18522,14 +20438,58 @@
       </p:sp>
       <p:sp>
         <p:nvSpPr>
-          <p:cNvPr id="16" name="TextBox 15"/>
+          <p:cNvPr id="19" name="Rounded Rectangle 18"/>
+          <p:cNvSpPr/>
+          <p:nvPr/>
+        </p:nvSpPr>
+        <p:spPr>
+          <a:xfrm>
+            <a:off x="7507224" y="2194560"/>
+            <a:ext cx="1691640" cy="64008"/>
+          </a:xfrm>
+          <a:prstGeom prst="roundRect">
+            <a:avLst/>
+          </a:prstGeom>
+          <a:solidFill>
+            <a:srgbClr val="F5A623"/>
+          </a:solidFill>
+          <a:ln>
+            <a:noFill/>
+          </a:ln>
+          <a:effectLst/>
+        </p:spPr>
+        <p:style>
+          <a:lnRef idx="1">
+            <a:schemeClr val="accent1"/>
+          </a:lnRef>
+          <a:fillRef idx="3">
+            <a:schemeClr val="accent1"/>
+          </a:fillRef>
+          <a:effectRef idx="2">
+            <a:schemeClr val="accent1"/>
+          </a:effectRef>
+          <a:fontRef idx="minor">
+            <a:schemeClr val="lt1"/>
+          </a:fontRef>
+        </p:style>
+        <p:txBody>
+          <a:bodyPr rtlCol="0" anchor="ctr"/>
+          <a:lstStyle/>
+          <a:p>
+            <a:pPr algn="ctr"/>
+          </a:p>
+        </p:txBody>
+      </p:sp>
+      <p:sp>
+        <p:nvSpPr>
+          <p:cNvPr id="20" name="TextBox 19"/>
           <p:cNvSpPr txBox="1"/>
           <p:nvPr/>
         </p:nvSpPr>
         <p:spPr>
           <a:xfrm>
-            <a:off x="7488936" y="2148840"/>
-            <a:ext cx="1728216" cy="1051560"/>
+            <a:off x="7488936" y="2203704"/>
+            <a:ext cx="1728216" cy="996695"/>
           </a:xfrm>
           <a:prstGeom prst="rect">
             <a:avLst/>
@@ -18589,7 +20549,7 @@
       </p:sp>
       <p:sp>
         <p:nvSpPr>
-          <p:cNvPr id="17" name="TextBox 16"/>
+          <p:cNvPr id="21" name="TextBox 20"/>
           <p:cNvSpPr txBox="1"/>
           <p:nvPr/>
         </p:nvSpPr>
@@ -18634,7 +20594,7 @@
       </p:sp>
       <p:sp>
         <p:nvSpPr>
-          <p:cNvPr id="18" name="Rounded Rectangle 17"/>
+          <p:cNvPr id="22" name="Rounded Rectangle 21"/>
           <p:cNvSpPr/>
           <p:nvPr/>
         </p:nvSpPr>
@@ -18680,14 +20640,58 @@
       </p:sp>
       <p:sp>
         <p:nvSpPr>
-          <p:cNvPr id="19" name="TextBox 18"/>
+          <p:cNvPr id="23" name="Rounded Rectangle 22"/>
+          <p:cNvSpPr/>
+          <p:nvPr/>
+        </p:nvSpPr>
+        <p:spPr>
+          <a:xfrm>
+            <a:off x="9765792" y="2194560"/>
+            <a:ext cx="1691640" cy="64008"/>
+          </a:xfrm>
+          <a:prstGeom prst="roundRect">
+            <a:avLst/>
+          </a:prstGeom>
+          <a:solidFill>
+            <a:srgbClr val="3FD0C8"/>
+          </a:solidFill>
+          <a:ln>
+            <a:noFill/>
+          </a:ln>
+          <a:effectLst/>
+        </p:spPr>
+        <p:style>
+          <a:lnRef idx="1">
+            <a:schemeClr val="accent1"/>
+          </a:lnRef>
+          <a:fillRef idx="3">
+            <a:schemeClr val="accent1"/>
+          </a:fillRef>
+          <a:effectRef idx="2">
+            <a:schemeClr val="accent1"/>
+          </a:effectRef>
+          <a:fontRef idx="minor">
+            <a:schemeClr val="lt1"/>
+          </a:fontRef>
+        </p:style>
+        <p:txBody>
+          <a:bodyPr rtlCol="0" anchor="ctr"/>
+          <a:lstStyle/>
+          <a:p>
+            <a:pPr algn="ctr"/>
+          </a:p>
+        </p:txBody>
+      </p:sp>
+      <p:sp>
+        <p:nvSpPr>
+          <p:cNvPr id="24" name="TextBox 23"/>
           <p:cNvSpPr txBox="1"/>
           <p:nvPr/>
         </p:nvSpPr>
         <p:spPr>
           <a:xfrm>
-            <a:off x="9747504" y="2148840"/>
-            <a:ext cx="1728216" cy="1051560"/>
+            <a:off x="9747504" y="2203704"/>
+            <a:ext cx="1728216" cy="996695"/>
           </a:xfrm>
           <a:prstGeom prst="rect">
             <a:avLst/>
@@ -18747,14 +20751,378 @@
       </p:sp>
       <p:sp>
         <p:nvSpPr>
-          <p:cNvPr id="20" name="Rounded Rectangle 19"/>
+          <p:cNvPr id="25" name="Rounded Rectangle 24"/>
           <p:cNvSpPr/>
           <p:nvPr/>
         </p:nvSpPr>
         <p:spPr>
           <a:xfrm>
-            <a:off x="640080" y="3794760"/>
-            <a:ext cx="10927080" cy="2331720"/>
+            <a:off x="2017623" y="3364992"/>
+            <a:ext cx="1563624" cy="384048"/>
+          </a:xfrm>
+          <a:prstGeom prst="roundRect">
+            <a:avLst/>
+          </a:prstGeom>
+          <a:solidFill>
+            <a:srgbClr val="161B22"/>
+          </a:solidFill>
+          <a:ln w="12700">
+            <a:solidFill>
+              <a:srgbClr val="30363D"/>
+            </a:solidFill>
+          </a:ln>
+          <a:effectLst/>
+        </p:spPr>
+        <p:style>
+          <a:lnRef idx="1">
+            <a:schemeClr val="accent1"/>
+          </a:lnRef>
+          <a:fillRef idx="3">
+            <a:schemeClr val="accent1"/>
+          </a:fillRef>
+          <a:effectRef idx="2">
+            <a:schemeClr val="accent1"/>
+          </a:effectRef>
+          <a:fontRef idx="minor">
+            <a:schemeClr val="lt1"/>
+          </a:fontRef>
+        </p:style>
+        <p:txBody>
+          <a:bodyPr rtlCol="0" anchor="ctr"/>
+          <a:lstStyle/>
+          <a:p>
+            <a:pPr algn="ctr"/>
+          </a:p>
+        </p:txBody>
+      </p:sp>
+      <p:sp>
+        <p:nvSpPr>
+          <p:cNvPr id="26" name="TextBox 25"/>
+          <p:cNvSpPr txBox="1"/>
+          <p:nvPr/>
+        </p:nvSpPr>
+        <p:spPr>
+          <a:xfrm>
+            <a:off x="2017623" y="3364992"/>
+            <a:ext cx="1563624" cy="384048"/>
+          </a:xfrm>
+          <a:prstGeom prst="rect">
+            <a:avLst/>
+          </a:prstGeom>
+          <a:noFill/>
+        </p:spPr>
+        <p:txBody>
+          <a:bodyPr wrap="square" anchor="ctr" lIns="0" rIns="0" tIns="0" bIns="0">
+            <a:spAutoFit/>
+          </a:bodyPr>
+          <a:lstStyle/>
+          <a:p>
+            <a:pPr algn="ctr">
+              <a:lnSpc>
+                <a:spcPct val="100000"/>
+              </a:lnSpc>
+              <a:spcBef>
+                <a:spcPts val="0"/>
+              </a:spcBef>
+              <a:spcAft>
+                <a:spcPts val="200"/>
+              </a:spcAft>
+            </a:pPr>
+            <a:r>
+              <a:rPr sz="1100" b="1">
+                <a:solidFill>
+                  <a:srgbClr val="F5A623"/>
+                </a:solidFill>
+                <a:latin typeface="Consolas"/>
+              </a:rPr>
+              <a:t>1 tail call</a:t>
+            </a:r>
+          </a:p>
+        </p:txBody>
+      </p:sp>
+      <p:sp>
+        <p:nvSpPr>
+          <p:cNvPr id="27" name="Rounded Rectangle 26"/>
+          <p:cNvSpPr/>
+          <p:nvPr/>
+        </p:nvSpPr>
+        <p:spPr>
+          <a:xfrm>
+            <a:off x="3745839" y="3364992"/>
+            <a:ext cx="2167128" cy="384048"/>
+          </a:xfrm>
+          <a:prstGeom prst="roundRect">
+            <a:avLst/>
+          </a:prstGeom>
+          <a:solidFill>
+            <a:srgbClr val="161B22"/>
+          </a:solidFill>
+          <a:ln w="12700">
+            <a:solidFill>
+              <a:srgbClr val="30363D"/>
+            </a:solidFill>
+          </a:ln>
+          <a:effectLst/>
+        </p:spPr>
+        <p:style>
+          <a:lnRef idx="1">
+            <a:schemeClr val="accent1"/>
+          </a:lnRef>
+          <a:fillRef idx="3">
+            <a:schemeClr val="accent1"/>
+          </a:fillRef>
+          <a:effectRef idx="2">
+            <a:schemeClr val="accent1"/>
+          </a:effectRef>
+          <a:fontRef idx="minor">
+            <a:schemeClr val="lt1"/>
+          </a:fontRef>
+        </p:style>
+        <p:txBody>
+          <a:bodyPr rtlCol="0" anchor="ctr"/>
+          <a:lstStyle/>
+          <a:p>
+            <a:pPr algn="ctr"/>
+          </a:p>
+        </p:txBody>
+      </p:sp>
+      <p:sp>
+        <p:nvSpPr>
+          <p:cNvPr id="28" name="TextBox 27"/>
+          <p:cNvSpPr txBox="1"/>
+          <p:nvPr/>
+        </p:nvSpPr>
+        <p:spPr>
+          <a:xfrm>
+            <a:off x="3745839" y="3364992"/>
+            <a:ext cx="2167128" cy="384048"/>
+          </a:xfrm>
+          <a:prstGeom prst="rect">
+            <a:avLst/>
+          </a:prstGeom>
+          <a:noFill/>
+        </p:spPr>
+        <p:txBody>
+          <a:bodyPr wrap="square" anchor="ctr" lIns="0" rIns="0" tIns="0" bIns="0">
+            <a:spAutoFit/>
+          </a:bodyPr>
+          <a:lstStyle/>
+          <a:p>
+            <a:pPr algn="ctr">
+              <a:lnSpc>
+                <a:spcPct val="100000"/>
+              </a:lnSpc>
+              <a:spcBef>
+                <a:spcPts val="0"/>
+              </a:spcBef>
+              <a:spcAft>
+                <a:spcPts val="200"/>
+              </a:spcAft>
+            </a:pPr>
+            <a:r>
+              <a:rPr sz="1100" b="1">
+                <a:solidFill>
+                  <a:srgbClr val="E6EDF3"/>
+                </a:solidFill>
+                <a:latin typeface="Consolas"/>
+              </a:rPr>
+              <a:t>~322 lookup / pkt</a:t>
+            </a:r>
+          </a:p>
+        </p:txBody>
+      </p:sp>
+      <p:sp>
+        <p:nvSpPr>
+          <p:cNvPr id="29" name="Rounded Rectangle 28"/>
+          <p:cNvSpPr/>
+          <p:nvPr/>
+        </p:nvSpPr>
+        <p:spPr>
+          <a:xfrm>
+            <a:off x="6077559" y="3364992"/>
+            <a:ext cx="1764792" cy="384048"/>
+          </a:xfrm>
+          <a:prstGeom prst="roundRect">
+            <a:avLst/>
+          </a:prstGeom>
+          <a:solidFill>
+            <a:srgbClr val="161B22"/>
+          </a:solidFill>
+          <a:ln w="12700">
+            <a:solidFill>
+              <a:srgbClr val="30363D"/>
+            </a:solidFill>
+          </a:ln>
+          <a:effectLst/>
+        </p:spPr>
+        <p:style>
+          <a:lnRef idx="1">
+            <a:schemeClr val="accent1"/>
+          </a:lnRef>
+          <a:fillRef idx="3">
+            <a:schemeClr val="accent1"/>
+          </a:fillRef>
+          <a:effectRef idx="2">
+            <a:schemeClr val="accent1"/>
+          </a:effectRef>
+          <a:fontRef idx="minor">
+            <a:schemeClr val="lt1"/>
+          </a:fontRef>
+        </p:style>
+        <p:txBody>
+          <a:bodyPr rtlCol="0" anchor="ctr"/>
+          <a:lstStyle/>
+          <a:p>
+            <a:pPr algn="ctr"/>
+          </a:p>
+        </p:txBody>
+      </p:sp>
+      <p:sp>
+        <p:nvSpPr>
+          <p:cNvPr id="30" name="TextBox 29"/>
+          <p:cNvSpPr txBox="1"/>
+          <p:nvPr/>
+        </p:nvSpPr>
+        <p:spPr>
+          <a:xfrm>
+            <a:off x="6077559" y="3364992"/>
+            <a:ext cx="1764792" cy="384048"/>
+          </a:xfrm>
+          <a:prstGeom prst="rect">
+            <a:avLst/>
+          </a:prstGeom>
+          <a:noFill/>
+        </p:spPr>
+        <p:txBody>
+          <a:bodyPr wrap="square" anchor="ctr" lIns="0" rIns="0" tIns="0" bIns="0">
+            <a:spAutoFit/>
+          </a:bodyPr>
+          <a:lstStyle/>
+          <a:p>
+            <a:pPr algn="ctr">
+              <a:lnSpc>
+                <a:spcPct val="100000"/>
+              </a:lnSpc>
+              <a:spcBef>
+                <a:spcPts val="0"/>
+              </a:spcBef>
+              <a:spcAft>
+                <a:spcPts val="200"/>
+              </a:spcAft>
+            </a:pPr>
+            <a:r>
+              <a:rPr sz="1100" b="1">
+                <a:solidFill>
+                  <a:srgbClr val="E6EDF3"/>
+                </a:solidFill>
+                <a:latin typeface="Consolas"/>
+              </a:rPr>
+              <a:t>15.8 KB mappe</a:t>
+            </a:r>
+          </a:p>
+        </p:txBody>
+      </p:sp>
+      <p:sp>
+        <p:nvSpPr>
+          <p:cNvPr id="31" name="Rounded Rectangle 30"/>
+          <p:cNvSpPr/>
+          <p:nvPr/>
+        </p:nvSpPr>
+        <p:spPr>
+          <a:xfrm>
+            <a:off x="8006943" y="3364992"/>
+            <a:ext cx="2167128" cy="384048"/>
+          </a:xfrm>
+          <a:prstGeom prst="roundRect">
+            <a:avLst/>
+          </a:prstGeom>
+          <a:solidFill>
+            <a:srgbClr val="161B22"/>
+          </a:solidFill>
+          <a:ln w="12700">
+            <a:solidFill>
+              <a:srgbClr val="30363D"/>
+            </a:solidFill>
+          </a:ln>
+          <a:effectLst/>
+        </p:spPr>
+        <p:style>
+          <a:lnRef idx="1">
+            <a:schemeClr val="accent1"/>
+          </a:lnRef>
+          <a:fillRef idx="3">
+            <a:schemeClr val="accent1"/>
+          </a:fillRef>
+          <a:effectRef idx="2">
+            <a:schemeClr val="accent1"/>
+          </a:effectRef>
+          <a:fontRef idx="minor">
+            <a:schemeClr val="lt1"/>
+          </a:fontRef>
+        </p:style>
+        <p:txBody>
+          <a:bodyPr rtlCol="0" anchor="ctr"/>
+          <a:lstStyle/>
+          <a:p>
+            <a:pPr algn="ctr"/>
+          </a:p>
+        </p:txBody>
+      </p:sp>
+      <p:sp>
+        <p:nvSpPr>
+          <p:cNvPr id="32" name="TextBox 31"/>
+          <p:cNvSpPr txBox="1"/>
+          <p:nvPr/>
+        </p:nvSpPr>
+        <p:spPr>
+          <a:xfrm>
+            <a:off x="8006943" y="3364992"/>
+            <a:ext cx="2167128" cy="384048"/>
+          </a:xfrm>
+          <a:prstGeom prst="rect">
+            <a:avLst/>
+          </a:prstGeom>
+          <a:noFill/>
+        </p:spPr>
+        <p:txBody>
+          <a:bodyPr wrap="square" anchor="ctr" lIns="0" rIns="0" tIns="0" bIns="0">
+            <a:spAutoFit/>
+          </a:bodyPr>
+          <a:lstStyle/>
+          <a:p>
+            <a:pPr algn="ctr">
+              <a:lnSpc>
+                <a:spcPct val="100000"/>
+              </a:lnSpc>
+              <a:spcBef>
+                <a:spcPts val="0"/>
+              </a:spcBef>
+              <a:spcAft>
+                <a:spcPts val="200"/>
+              </a:spcAft>
+            </a:pPr>
+            <a:r>
+              <a:rPr sz="1100" b="1">
+                <a:solidFill>
+                  <a:srgbClr val="F5A623"/>
+                </a:solidFill>
+                <a:latin typeface="Consolas"/>
+              </a:rPr>
+              <a:t>287 ns · 3.5 Mpps</a:t>
+            </a:r>
+          </a:p>
+        </p:txBody>
+      </p:sp>
+      <p:sp>
+        <p:nvSpPr>
+          <p:cNvPr id="33" name="Rounded Rectangle 32"/>
+          <p:cNvSpPr/>
+          <p:nvPr/>
+        </p:nvSpPr>
+        <p:spPr>
+          <a:xfrm>
+            <a:off x="640080" y="3840480"/>
+            <a:ext cx="10927080" cy="2286000"/>
           </a:xfrm>
           <a:prstGeom prst="roundRect">
             <a:avLst/>
@@ -18793,14 +21161,14 @@
       </p:sp>
       <p:sp>
         <p:nvSpPr>
-          <p:cNvPr id="21" name="TextBox 20"/>
+          <p:cNvPr id="34" name="TextBox 33"/>
           <p:cNvSpPr txBox="1"/>
           <p:nvPr/>
         </p:nvSpPr>
         <p:spPr>
           <a:xfrm>
-            <a:off x="896112" y="3995928"/>
-            <a:ext cx="10469880" cy="1965960"/>
+            <a:off x="896112" y="4041648"/>
+            <a:ext cx="10469880" cy="1920240"/>
           </a:xfrm>
           <a:prstGeom prst="rect">
             <a:avLst/>

</xml_diff>

<commit_message>
Update docs with fresh kernel numbers after mac_table + ctx fix
Kernel suite now PASS (5/5 per pipeline + link_state reroute). Latency
improved across the board vs the last measured baseline (P1 32ns, P2
125ns, P3 590ns) and mac_table shrank map memory as expected (P2
15796->7560B, P3 28468->20232B) and instructions (P2 2668->2618, P3
13645->13441). Updated HTML, testing.md, and the PPT deck to match, and
dropped stale ctx_in/xdp_md wording now that the verifier no longer
forces a custom context.

Co-Authored-By: Claude Sonnet 5 <noreply@anthropic.com>
</commit_message>
<xml_diff>
--- a/docs/IPA_eBPF_pipelines.pptx
+++ b/docs/IPA_eBPF_pipelines.pptx
@@ -4786,7 +4786,7 @@
         </p:nvSpPr>
         <p:spPr>
           <a:xfrm>
-            <a:off x="1917039" y="3364992"/>
+            <a:off x="1967331" y="3364992"/>
             <a:ext cx="1563624" cy="384048"/>
           </a:xfrm>
           <a:prstGeom prst="roundRect">
@@ -4832,7 +4832,7 @@
         </p:nvSpPr>
         <p:spPr>
           <a:xfrm>
-            <a:off x="1917039" y="3364992"/>
+            <a:off x="1967331" y="3364992"/>
             <a:ext cx="1563624" cy="384048"/>
           </a:xfrm>
           <a:prstGeom prst="rect">
@@ -4877,7 +4877,7 @@
         </p:nvSpPr>
         <p:spPr>
           <a:xfrm>
-            <a:off x="3645255" y="3364992"/>
+            <a:off x="3695547" y="3364992"/>
             <a:ext cx="2167128" cy="384048"/>
           </a:xfrm>
           <a:prstGeom prst="roundRect">
@@ -4923,7 +4923,7 @@
         </p:nvSpPr>
         <p:spPr>
           <a:xfrm>
-            <a:off x="3645255" y="3364992"/>
+            <a:off x="3695547" y="3364992"/>
             <a:ext cx="2167128" cy="384048"/>
           </a:xfrm>
           <a:prstGeom prst="rect">
@@ -4968,7 +4968,7 @@
         </p:nvSpPr>
         <p:spPr>
           <a:xfrm>
-            <a:off x="5976975" y="3364992"/>
+            <a:off x="6027267" y="3364992"/>
             <a:ext cx="1764792" cy="384048"/>
           </a:xfrm>
           <a:prstGeom prst="roundRect">
@@ -5014,7 +5014,7 @@
         </p:nvSpPr>
         <p:spPr>
           <a:xfrm>
-            <a:off x="5976975" y="3364992"/>
+            <a:off x="6027267" y="3364992"/>
             <a:ext cx="1764792" cy="384048"/>
           </a:xfrm>
           <a:prstGeom prst="rect">
@@ -5046,7 +5046,7 @@
                 </a:solidFill>
                 <a:latin typeface="Consolas"/>
               </a:rPr>
-              <a:t>28.5 KB mappe</a:t>
+              <a:t>19.8 KB mappe</a:t>
             </a:r>
           </a:p>
         </p:txBody>
@@ -5059,8 +5059,8 @@
         </p:nvSpPr>
         <p:spPr>
           <a:xfrm>
-            <a:off x="7906359" y="3364992"/>
-            <a:ext cx="2368296" cy="384048"/>
+            <a:off x="7956651" y="3364992"/>
+            <a:ext cx="2267712" cy="384048"/>
           </a:xfrm>
           <a:prstGeom prst="roundRect">
             <a:avLst/>
@@ -5105,8 +5105,8 @@
         </p:nvSpPr>
         <p:spPr>
           <a:xfrm>
-            <a:off x="7906359" y="3364992"/>
-            <a:ext cx="2368296" cy="384048"/>
+            <a:off x="7956651" y="3364992"/>
+            <a:ext cx="2267712" cy="384048"/>
           </a:xfrm>
           <a:prstGeom prst="rect">
             <a:avLst/>
@@ -5137,7 +5137,7 @@
                 </a:solidFill>
                 <a:latin typeface="Consolas"/>
               </a:rPr>
-              <a:t>1274 ns · 0.79 Mpps</a:t>
+              <a:t>590 ns · 1.70 Mpps</a:t>
             </a:r>
           </a:p>
         </p:txBody>
@@ -8046,7 +8046,7 @@
                 </a:solidFill>
                 <a:latin typeface="Segoe UI"/>
               </a:rPr>
-              <a:t>Un xdp_md azzerato come contesto pin-a ingress_ifindex=0 (risolve il vecchio drift del template). </a:t>
+              <a:t>Nessun ctx custom: sotto TEST_RUN l'ingress_ifindex di sandbox cade fuori dai range attesi di tutte e 3, quindi combaciano allo stesso modo col riferimento Python. </a:t>
             </a:r>
           </a:p>
           <a:p>
@@ -8539,7 +8539,7 @@
                           </a:solidFill>
                           <a:latin typeface="Consolas"/>
                         </a:rPr>
-                        <a:t>2 668</a:t>
+                        <a:t>2 618</a:t>
                       </a:r>
                     </a:p>
                   </a:txBody>
@@ -8562,7 +8562,7 @@
                           </a:solidFill>
                           <a:latin typeface="Consolas"/>
                         </a:rPr>
-                        <a:t>13 645</a:t>
+                        <a:t>13 441</a:t>
                       </a:r>
                     </a:p>
                   </a:txBody>
@@ -8633,7 +8633,7 @@
                           </a:solidFill>
                           <a:latin typeface="Consolas"/>
                         </a:rPr>
-                        <a:t>12 575</a:t>
+                        <a:t>11 464</a:t>
                       </a:r>
                     </a:p>
                   </a:txBody>
@@ -8656,7 +8656,7 @@
                           </a:solidFill>
                           <a:latin typeface="Consolas"/>
                         </a:rPr>
-                        <a:t>58 146</a:t>
+                        <a:t>57 224</a:t>
                       </a:r>
                     </a:p>
                   </a:txBody>
@@ -8915,7 +8915,7 @@
                           </a:solidFill>
                           <a:latin typeface="Consolas"/>
                         </a:rPr>
-                        <a:t>15 796</a:t>
+                        <a:t>7 560</a:t>
                       </a:r>
                     </a:p>
                   </a:txBody>
@@ -8938,7 +8938,7 @@
                           </a:solidFill>
                           <a:latin typeface="Consolas"/>
                         </a:rPr>
-                        <a:t>28 468</a:t>
+                        <a:t>20 232</a:t>
                       </a:r>
                     </a:p>
                   </a:txBody>
@@ -8986,7 +8986,7 @@
                           </a:solidFill>
                           <a:latin typeface="Consolas"/>
                         </a:rPr>
-                        <a:t>72.0</a:t>
+                        <a:t>32.0</a:t>
                       </a:r>
                     </a:p>
                   </a:txBody>
@@ -9009,7 +9009,7 @@
                           </a:solidFill>
                           <a:latin typeface="Consolas"/>
                         </a:rPr>
-                        <a:t>287.0</a:t>
+                        <a:t>125.0</a:t>
                       </a:r>
                     </a:p>
                   </a:txBody>
@@ -9032,7 +9032,7 @@
                           </a:solidFill>
                           <a:latin typeface="Consolas"/>
                         </a:rPr>
-                        <a:t>1274.0</a:t>
+                        <a:t>590.0</a:t>
                       </a:r>
                     </a:p>
                   </a:txBody>
@@ -9080,7 +9080,7 @@
                           </a:solidFill>
                           <a:latin typeface="Consolas"/>
                         </a:rPr>
-                        <a:t>13.889</a:t>
+                        <a:t>31.250</a:t>
                       </a:r>
                     </a:p>
                   </a:txBody>
@@ -9103,7 +9103,7 @@
                           </a:solidFill>
                           <a:latin typeface="Consolas"/>
                         </a:rPr>
-                        <a:t>3.484</a:t>
+                        <a:t>8.000</a:t>
                       </a:r>
                     </a:p>
                   </a:txBody>
@@ -9126,7 +9126,7 @@
                           </a:solidFill>
                           <a:latin typeface="Consolas"/>
                         </a:rPr>
-                        <a:t>0.785</a:t>
+                        <a:t>1.695</a:t>
                       </a:r>
                     </a:p>
                   </a:txBody>
@@ -9174,7 +9174,7 @@
                           </a:solidFill>
                           <a:latin typeface="Consolas"/>
                         </a:rPr>
-                        <a:t>58</a:t>
+                        <a:t>38</a:t>
                       </a:r>
                     </a:p>
                   </a:txBody>
@@ -9197,7 +9197,7 @@
                           </a:solidFill>
                           <a:latin typeface="Consolas"/>
                         </a:rPr>
-                        <a:t>61</a:t>
+                        <a:t>53</a:t>
                       </a:r>
                     </a:p>
                   </a:txBody>
@@ -9220,7 +9220,7 @@
                           </a:solidFill>
                           <a:latin typeface="Consolas"/>
                         </a:rPr>
-                        <a:t>80</a:t>
+                        <a:t>60</a:t>
                       </a:r>
                     </a:p>
                   </a:txBody>
@@ -9352,7 +9352,7 @@
                 </a:solidFill>
                 <a:latin typeface="Segoe UI"/>
               </a:rPr>
-              <a:t>P1 più veloce: 72 ns, 13.9 Mpps.</a:t>
+              <a:t>P1 più veloce: 32 ns, 31.3 Mpps.</a:t>
             </a:r>
           </a:p>
           <a:p>
@@ -9445,7 +9445,7 @@
                 </a:solidFill>
                 <a:latin typeface="Segoe UI"/>
               </a:rPr>
-              <a:t>P3 ≈12× istruzioni di P1.</a:t>
+              <a:t>P3 ≈13× istruzioni di P1.</a:t>
             </a:r>
           </a:p>
         </p:txBody>
@@ -9490,7 +9490,7 @@
                 </a:solidFill>
                 <a:latin typeface="Segoe UI"/>
               </a:rPr>
-              <a:t>Confronto pulito: </a:t>
+              <a:t>mac_table: </a:t>
             </a:r>
             <a:r>
               <a:rPr sz="1200" b="0">
@@ -9499,7 +9499,7 @@
                 </a:solidFill>
                 <a:latin typeface="Segoe UI"/>
               </a:rPr>
-              <a:t>P1 è sceso da 1109 a 72 ns rimuovendo 3 bpf_trace_printk per pacchetto (assenti in P2/P3) che falsavano il baseline. L'inferenza è identica nelle 3 (classe kernel = riferimento Python); differisce solo il design. Ordine coerente con la tassonomia.</a:t>
+              <a:t>argmax → mac_table[classe] → bpf_redirect su tutte e 3 (P1 hardcoded in uno switch, 0 lookup). L'inferenza è identica nelle 3 (classe kernel = riferimento Python); differisce solo il design. Ordine coerente con la tassonomia.</a:t>
             </a:r>
           </a:p>
         </p:txBody>
@@ -18565,7 +18565,7 @@
                 </a:solidFill>
                 <a:latin typeface="Consolas"/>
               </a:rPr>
-              <a:t>72 ns · 13.9 Mpps</a:t>
+              <a:t>32 ns · 31.3 Mpps</a:t>
             </a:r>
           </a:p>
         </p:txBody>
@@ -20757,7 +20757,7 @@
         </p:nvSpPr>
         <p:spPr>
           <a:xfrm>
-            <a:off x="2017623" y="3364992"/>
+            <a:off x="2067915" y="3364992"/>
             <a:ext cx="1563624" cy="384048"/>
           </a:xfrm>
           <a:prstGeom prst="roundRect">
@@ -20803,7 +20803,7 @@
         </p:nvSpPr>
         <p:spPr>
           <a:xfrm>
-            <a:off x="2017623" y="3364992"/>
+            <a:off x="2067915" y="3364992"/>
             <a:ext cx="1563624" cy="384048"/>
           </a:xfrm>
           <a:prstGeom prst="rect">
@@ -20848,7 +20848,7 @@
         </p:nvSpPr>
         <p:spPr>
           <a:xfrm>
-            <a:off x="3745839" y="3364992"/>
+            <a:off x="3796131" y="3364992"/>
             <a:ext cx="2167128" cy="384048"/>
           </a:xfrm>
           <a:prstGeom prst="roundRect">
@@ -20894,7 +20894,7 @@
         </p:nvSpPr>
         <p:spPr>
           <a:xfrm>
-            <a:off x="3745839" y="3364992"/>
+            <a:off x="3796131" y="3364992"/>
             <a:ext cx="2167128" cy="384048"/>
           </a:xfrm>
           <a:prstGeom prst="rect">
@@ -20939,8 +20939,8 @@
         </p:nvSpPr>
         <p:spPr>
           <a:xfrm>
-            <a:off x="6077559" y="3364992"/>
-            <a:ext cx="1764792" cy="384048"/>
+            <a:off x="6127851" y="3364992"/>
+            <a:ext cx="1664208" cy="384048"/>
           </a:xfrm>
           <a:prstGeom prst="roundRect">
             <a:avLst/>
@@ -20985,8 +20985,8 @@
         </p:nvSpPr>
         <p:spPr>
           <a:xfrm>
-            <a:off x="6077559" y="3364992"/>
-            <a:ext cx="1764792" cy="384048"/>
+            <a:off x="6127851" y="3364992"/>
+            <a:ext cx="1664208" cy="384048"/>
           </a:xfrm>
           <a:prstGeom prst="rect">
             <a:avLst/>
@@ -21017,7 +21017,7 @@
                 </a:solidFill>
                 <a:latin typeface="Consolas"/>
               </a:rPr>
-              <a:t>15.8 KB mappe</a:t>
+              <a:t>7.4 KB mappe</a:t>
             </a:r>
           </a:p>
         </p:txBody>
@@ -21030,7 +21030,7 @@
         </p:nvSpPr>
         <p:spPr>
           <a:xfrm>
-            <a:off x="8006943" y="3364992"/>
+            <a:off x="7956651" y="3364992"/>
             <a:ext cx="2167128" cy="384048"/>
           </a:xfrm>
           <a:prstGeom prst="roundRect">
@@ -21076,7 +21076,7 @@
         </p:nvSpPr>
         <p:spPr>
           <a:xfrm>
-            <a:off x="8006943" y="3364992"/>
+            <a:off x="7956651" y="3364992"/>
             <a:ext cx="2167128" cy="384048"/>
           </a:xfrm>
           <a:prstGeom prst="rect">
@@ -21108,7 +21108,7 @@
                 </a:solidFill>
                 <a:latin typeface="Consolas"/>
               </a:rPr>
-              <a:t>287 ns · 3.5 Mpps</a:t>
+              <a:t>125 ns · 8.0 Mpps</a:t>
             </a:r>
           </a:p>
         </p:txBody>
@@ -22147,7 +22147,7 @@
                 </a:solidFill>
                 <a:latin typeface="Segoe UI"/>
               </a:rPr>
-              <a:t>Prestazioni intermedie (287 ns): tra P1 hardcoded e P3 modular.</a:t>
+              <a:t>Prestazioni intermedie (125 ns): tra P1 hardcoded e P3 modular.</a:t>
             </a:r>
           </a:p>
         </p:txBody>

</xml_diff>